<commit_message>
feat: enhance PowerPoint generation by adding formula rendering capabilities and updating normalization formulas for improved clarity and presentation quality
</commit_message>
<xml_diff>
--- a/web-presentation/pdf-exports/Week1-Session1-Foundations.pptx
+++ b/web-presentation/pdf-exports/Week1-Session1-Foundations.pptx
@@ -10419,7 +10419,99 @@
                 <a:ea typeface="DIN Next LT W23"/>
                 <a:cs typeface="DIN Next LT W23"/>
               </a:rPr>
-              <a:t>x_norm = (x − x_min) / (x_max − x_min)</a:t>
+              <a:t>x</a:t>
+            </a:r>
+            <a:r>
+              <a:rPr sz="1600" b="1">
+                <a:solidFill>
+                  <a:srgbClr val="5234B7"/>
+                </a:solidFill>
+                <a:latin typeface="DIN Next LT W23"/>
+                <a:ea typeface="DIN Next LT W23"/>
+                <a:cs typeface="DIN Next LT W23"/>
+                <a:baseline val="-25000"/>
+              </a:rPr>
+              <a:t>norm</a:t>
+            </a:r>
+            <a:r>
+              <a:rPr sz="2200" b="1">
+                <a:solidFill>
+                  <a:srgbClr val="5234B7"/>
+                </a:solidFill>
+                <a:latin typeface="DIN Next LT W23"/>
+                <a:ea typeface="DIN Next LT W23"/>
+                <a:cs typeface="DIN Next LT W23"/>
+              </a:rPr>
+              <a:t> = (x − x</a:t>
+            </a:r>
+            <a:r>
+              <a:rPr sz="1600" b="1">
+                <a:solidFill>
+                  <a:srgbClr val="5234B7"/>
+                </a:solidFill>
+                <a:latin typeface="DIN Next LT W23"/>
+                <a:ea typeface="DIN Next LT W23"/>
+                <a:cs typeface="DIN Next LT W23"/>
+                <a:baseline val="-25000"/>
+              </a:rPr>
+              <a:t>min</a:t>
+            </a:r>
+            <a:r>
+              <a:rPr sz="2200" b="1">
+                <a:solidFill>
+                  <a:srgbClr val="5234B7"/>
+                </a:solidFill>
+                <a:latin typeface="DIN Next LT W23"/>
+                <a:ea typeface="DIN Next LT W23"/>
+                <a:cs typeface="DIN Next LT W23"/>
+              </a:rPr>
+              <a:t>) / (x</a:t>
+            </a:r>
+            <a:r>
+              <a:rPr sz="1600" b="1">
+                <a:solidFill>
+                  <a:srgbClr val="5234B7"/>
+                </a:solidFill>
+                <a:latin typeface="DIN Next LT W23"/>
+                <a:ea typeface="DIN Next LT W23"/>
+                <a:cs typeface="DIN Next LT W23"/>
+                <a:baseline val="-25000"/>
+              </a:rPr>
+              <a:t>max</a:t>
+            </a:r>
+            <a:r>
+              <a:rPr sz="2200" b="1">
+                <a:solidFill>
+                  <a:srgbClr val="5234B7"/>
+                </a:solidFill>
+                <a:latin typeface="DIN Next LT W23"/>
+                <a:ea typeface="DIN Next LT W23"/>
+                <a:cs typeface="DIN Next LT W23"/>
+              </a:rPr>
+              <a:t> − x</a:t>
+            </a:r>
+            <a:r>
+              <a:rPr sz="1600" b="1">
+                <a:solidFill>
+                  <a:srgbClr val="5234B7"/>
+                </a:solidFill>
+                <a:latin typeface="DIN Next LT W23"/>
+                <a:ea typeface="DIN Next LT W23"/>
+                <a:cs typeface="DIN Next LT W23"/>
+                <a:baseline val="-25000"/>
+              </a:rPr>
+              <a:t>min</a:t>
+            </a:r>
+            <a:r>
+              <a:rPr sz="2200" b="1">
+                <a:solidFill>
+                  <a:srgbClr val="5234B7"/>
+                </a:solidFill>
+                <a:latin typeface="DIN Next LT W23"/>
+                <a:ea typeface="DIN Next LT W23"/>
+                <a:cs typeface="DIN Next LT W23"/>
+              </a:rPr>
+              <a:t>)</a:t>
             </a:r>
           </a:p>
         </p:txBody>
@@ -15423,7 +15515,99 @@
                 <a:ea typeface="DIN Next LT W23"/>
                 <a:cs typeface="DIN Next LT W23"/>
               </a:rPr>
-              <a:t>x_norm = (x − x_min) / (x_max − x_min)</a:t>
+              <a:t>x</a:t>
+            </a:r>
+            <a:r>
+              <a:rPr sz="1200" b="1">
+                <a:solidFill>
+                  <a:srgbClr val="5234B7"/>
+                </a:solidFill>
+                <a:latin typeface="DIN Next LT W23"/>
+                <a:ea typeface="DIN Next LT W23"/>
+                <a:cs typeface="DIN Next LT W23"/>
+                <a:baseline val="-25000"/>
+              </a:rPr>
+              <a:t>norm</a:t>
+            </a:r>
+            <a:r>
+              <a:rPr sz="1800" b="1">
+                <a:solidFill>
+                  <a:srgbClr val="5234B7"/>
+                </a:solidFill>
+                <a:latin typeface="DIN Next LT W23"/>
+                <a:ea typeface="DIN Next LT W23"/>
+                <a:cs typeface="DIN Next LT W23"/>
+              </a:rPr>
+              <a:t> = (x − x</a:t>
+            </a:r>
+            <a:r>
+              <a:rPr sz="1200" b="1">
+                <a:solidFill>
+                  <a:srgbClr val="5234B7"/>
+                </a:solidFill>
+                <a:latin typeface="DIN Next LT W23"/>
+                <a:ea typeface="DIN Next LT W23"/>
+                <a:cs typeface="DIN Next LT W23"/>
+                <a:baseline val="-25000"/>
+              </a:rPr>
+              <a:t>min</a:t>
+            </a:r>
+            <a:r>
+              <a:rPr sz="1800" b="1">
+                <a:solidFill>
+                  <a:srgbClr val="5234B7"/>
+                </a:solidFill>
+                <a:latin typeface="DIN Next LT W23"/>
+                <a:ea typeface="DIN Next LT W23"/>
+                <a:cs typeface="DIN Next LT W23"/>
+              </a:rPr>
+              <a:t>) / (x</a:t>
+            </a:r>
+            <a:r>
+              <a:rPr sz="1200" b="1">
+                <a:solidFill>
+                  <a:srgbClr val="5234B7"/>
+                </a:solidFill>
+                <a:latin typeface="DIN Next LT W23"/>
+                <a:ea typeface="DIN Next LT W23"/>
+                <a:cs typeface="DIN Next LT W23"/>
+                <a:baseline val="-25000"/>
+              </a:rPr>
+              <a:t>max</a:t>
+            </a:r>
+            <a:r>
+              <a:rPr sz="1800" b="1">
+                <a:solidFill>
+                  <a:srgbClr val="5234B7"/>
+                </a:solidFill>
+                <a:latin typeface="DIN Next LT W23"/>
+                <a:ea typeface="DIN Next LT W23"/>
+                <a:cs typeface="DIN Next LT W23"/>
+              </a:rPr>
+              <a:t> − x</a:t>
+            </a:r>
+            <a:r>
+              <a:rPr sz="1200" b="1">
+                <a:solidFill>
+                  <a:srgbClr val="5234B7"/>
+                </a:solidFill>
+                <a:latin typeface="DIN Next LT W23"/>
+                <a:ea typeface="DIN Next LT W23"/>
+                <a:cs typeface="DIN Next LT W23"/>
+                <a:baseline val="-25000"/>
+              </a:rPr>
+              <a:t>min</a:t>
+            </a:r>
+            <a:r>
+              <a:rPr sz="1800" b="1">
+                <a:solidFill>
+                  <a:srgbClr val="5234B7"/>
+                </a:solidFill>
+                <a:latin typeface="DIN Next LT W23"/>
+                <a:ea typeface="DIN Next LT W23"/>
+                <a:cs typeface="DIN Next LT W23"/>
+              </a:rPr>
+              <a:t>)</a:t>
             </a:r>
           </a:p>
         </p:txBody>
@@ -15460,7 +15644,53 @@
                 <a:ea typeface="DIN Next LT W23"/>
                 <a:cs typeface="DIN Next LT W23"/>
               </a:rPr>
-              <a:t>x_min = 20 · x_max = 100</a:t>
+              <a:t>x</a:t>
+            </a:r>
+            <a:r>
+              <a:rPr sz="1100" b="0">
+                <a:solidFill>
+                  <a:srgbClr val="5A5470"/>
+                </a:solidFill>
+                <a:latin typeface="DIN Next LT W23"/>
+                <a:ea typeface="DIN Next LT W23"/>
+                <a:cs typeface="DIN Next LT W23"/>
+                <a:baseline val="-25000"/>
+              </a:rPr>
+              <a:t>min</a:t>
+            </a:r>
+            <a:r>
+              <a:rPr sz="1300" b="0">
+                <a:solidFill>
+                  <a:srgbClr val="5A5470"/>
+                </a:solidFill>
+                <a:latin typeface="DIN Next LT W23"/>
+                <a:ea typeface="DIN Next LT W23"/>
+                <a:cs typeface="DIN Next LT W23"/>
+              </a:rPr>
+              <a:t> = 20 · x</a:t>
+            </a:r>
+            <a:r>
+              <a:rPr sz="1100" b="0">
+                <a:solidFill>
+                  <a:srgbClr val="5A5470"/>
+                </a:solidFill>
+                <a:latin typeface="DIN Next LT W23"/>
+                <a:ea typeface="DIN Next LT W23"/>
+                <a:cs typeface="DIN Next LT W23"/>
+                <a:baseline val="-25000"/>
+              </a:rPr>
+              <a:t>max</a:t>
+            </a:r>
+            <a:r>
+              <a:rPr sz="1300" b="0">
+                <a:solidFill>
+                  <a:srgbClr val="5A5470"/>
+                </a:solidFill>
+                <a:latin typeface="DIN Next LT W23"/>
+                <a:ea typeface="DIN Next LT W23"/>
+                <a:cs typeface="DIN Next LT W23"/>
+              </a:rPr>
+              <a:t> = 100</a:t>
             </a:r>
           </a:p>
         </p:txBody>
@@ -16510,7 +16740,99 @@
                 <a:ea typeface="DIN Next LT W23"/>
                 <a:cs typeface="DIN Next LT W23"/>
               </a:rPr>
-              <a:t>x_norm = (x − x_min) / (x_max − x_min)</a:t>
+              <a:t>x</a:t>
+            </a:r>
+            <a:r>
+              <a:rPr sz="1200" b="1">
+                <a:solidFill>
+                  <a:srgbClr val="5234B7"/>
+                </a:solidFill>
+                <a:latin typeface="DIN Next LT W23"/>
+                <a:ea typeface="DIN Next LT W23"/>
+                <a:cs typeface="DIN Next LT W23"/>
+                <a:baseline val="-25000"/>
+              </a:rPr>
+              <a:t>norm</a:t>
+            </a:r>
+            <a:r>
+              <a:rPr sz="1800" b="1">
+                <a:solidFill>
+                  <a:srgbClr val="5234B7"/>
+                </a:solidFill>
+                <a:latin typeface="DIN Next LT W23"/>
+                <a:ea typeface="DIN Next LT W23"/>
+                <a:cs typeface="DIN Next LT W23"/>
+              </a:rPr>
+              <a:t> = (x − x</a:t>
+            </a:r>
+            <a:r>
+              <a:rPr sz="1200" b="1">
+                <a:solidFill>
+                  <a:srgbClr val="5234B7"/>
+                </a:solidFill>
+                <a:latin typeface="DIN Next LT W23"/>
+                <a:ea typeface="DIN Next LT W23"/>
+                <a:cs typeface="DIN Next LT W23"/>
+                <a:baseline val="-25000"/>
+              </a:rPr>
+              <a:t>min</a:t>
+            </a:r>
+            <a:r>
+              <a:rPr sz="1800" b="1">
+                <a:solidFill>
+                  <a:srgbClr val="5234B7"/>
+                </a:solidFill>
+                <a:latin typeface="DIN Next LT W23"/>
+                <a:ea typeface="DIN Next LT W23"/>
+                <a:cs typeface="DIN Next LT W23"/>
+              </a:rPr>
+              <a:t>) / (x</a:t>
+            </a:r>
+            <a:r>
+              <a:rPr sz="1200" b="1">
+                <a:solidFill>
+                  <a:srgbClr val="5234B7"/>
+                </a:solidFill>
+                <a:latin typeface="DIN Next LT W23"/>
+                <a:ea typeface="DIN Next LT W23"/>
+                <a:cs typeface="DIN Next LT W23"/>
+                <a:baseline val="-25000"/>
+              </a:rPr>
+              <a:t>max</a:t>
+            </a:r>
+            <a:r>
+              <a:rPr sz="1800" b="1">
+                <a:solidFill>
+                  <a:srgbClr val="5234B7"/>
+                </a:solidFill>
+                <a:latin typeface="DIN Next LT W23"/>
+                <a:ea typeface="DIN Next LT W23"/>
+                <a:cs typeface="DIN Next LT W23"/>
+              </a:rPr>
+              <a:t> − x</a:t>
+            </a:r>
+            <a:r>
+              <a:rPr sz="1200" b="1">
+                <a:solidFill>
+                  <a:srgbClr val="5234B7"/>
+                </a:solidFill>
+                <a:latin typeface="DIN Next LT W23"/>
+                <a:ea typeface="DIN Next LT W23"/>
+                <a:cs typeface="DIN Next LT W23"/>
+                <a:baseline val="-25000"/>
+              </a:rPr>
+              <a:t>min</a:t>
+            </a:r>
+            <a:r>
+              <a:rPr sz="1800" b="1">
+                <a:solidFill>
+                  <a:srgbClr val="5234B7"/>
+                </a:solidFill>
+                <a:latin typeface="DIN Next LT W23"/>
+                <a:ea typeface="DIN Next LT W23"/>
+                <a:cs typeface="DIN Next LT W23"/>
+              </a:rPr>
+              <a:t>)</a:t>
             </a:r>
           </a:p>
         </p:txBody>
@@ -16547,7 +16869,53 @@
                 <a:ea typeface="DIN Next LT W23"/>
                 <a:cs typeface="DIN Next LT W23"/>
               </a:rPr>
-              <a:t>x_min = 20 · x_max = 100</a:t>
+              <a:t>x</a:t>
+            </a:r>
+            <a:r>
+              <a:rPr sz="1100" b="0">
+                <a:solidFill>
+                  <a:srgbClr val="5A5470"/>
+                </a:solidFill>
+                <a:latin typeface="DIN Next LT W23"/>
+                <a:ea typeface="DIN Next LT W23"/>
+                <a:cs typeface="DIN Next LT W23"/>
+                <a:baseline val="-25000"/>
+              </a:rPr>
+              <a:t>min</a:t>
+            </a:r>
+            <a:r>
+              <a:rPr sz="1300" b="0">
+                <a:solidFill>
+                  <a:srgbClr val="5A5470"/>
+                </a:solidFill>
+                <a:latin typeface="DIN Next LT W23"/>
+                <a:ea typeface="DIN Next LT W23"/>
+                <a:cs typeface="DIN Next LT W23"/>
+              </a:rPr>
+              <a:t> = 20 · x</a:t>
+            </a:r>
+            <a:r>
+              <a:rPr sz="1100" b="0">
+                <a:solidFill>
+                  <a:srgbClr val="5A5470"/>
+                </a:solidFill>
+                <a:latin typeface="DIN Next LT W23"/>
+                <a:ea typeface="DIN Next LT W23"/>
+                <a:cs typeface="DIN Next LT W23"/>
+                <a:baseline val="-25000"/>
+              </a:rPr>
+              <a:t>max</a:t>
+            </a:r>
+            <a:r>
+              <a:rPr sz="1300" b="0">
+                <a:solidFill>
+                  <a:srgbClr val="5A5470"/>
+                </a:solidFill>
+                <a:latin typeface="DIN Next LT W23"/>
+                <a:ea typeface="DIN Next LT W23"/>
+                <a:cs typeface="DIN Next LT W23"/>
+              </a:rPr>
+              <a:t> = 100</a:t>
             </a:r>
           </a:p>
         </p:txBody>
@@ -16611,7 +16979,7 @@
                           </a:solidFill>
                           <a:latin typeface="Helvetica"/>
                         </a:rPr>
-                        <a:t>Normalized value (x_norm)</a:t>
+                        <a:t>Normalized value (xₙₒᵣₘ)</a:t>
                       </a:r>
                     </a:p>
                   </a:txBody>
@@ -43330,7 +43698,30 @@
                 <a:ea typeface="DIN Next LT W23"/>
                 <a:cs typeface="DIN Next LT W23"/>
               </a:rPr>
-              <a:t>Study Hours_C = (8 + 7) / 2 = 7.5</a:t>
+              <a:t>Study Hours</a:t>
+            </a:r>
+            <a:r>
+              <a:rPr sz="1600" b="1">
+                <a:solidFill>
+                  <a:srgbClr val="5234B7"/>
+                </a:solidFill>
+                <a:latin typeface="DIN Next LT W23"/>
+                <a:ea typeface="DIN Next LT W23"/>
+                <a:cs typeface="DIN Next LT W23"/>
+                <a:baseline val="-25000"/>
+              </a:rPr>
+              <a:t>C</a:t>
+            </a:r>
+            <a:r>
+              <a:rPr sz="2200" b="1">
+                <a:solidFill>
+                  <a:srgbClr val="5234B7"/>
+                </a:solidFill>
+                <a:latin typeface="DIN Next LT W23"/>
+                <a:ea typeface="DIN Next LT W23"/>
+                <a:cs typeface="DIN Next LT W23"/>
+              </a:rPr>
+              <a:t> = (8 + 7) / 2 = 7.5</a:t>
             </a:r>
           </a:p>
         </p:txBody>
@@ -44785,7 +45176,30 @@
                 <a:ea typeface="DIN Next LT W23"/>
                 <a:cs typeface="DIN Next LT W23"/>
               </a:rPr>
-              <a:t>Study Hours_C ≈ 7.6</a:t>
+              <a:t>Study Hours</a:t>
+            </a:r>
+            <a:r>
+              <a:rPr sz="1600" b="1">
+                <a:solidFill>
+                  <a:srgbClr val="5234B7"/>
+                </a:solidFill>
+                <a:latin typeface="DIN Next LT W23"/>
+                <a:ea typeface="DIN Next LT W23"/>
+                <a:cs typeface="DIN Next LT W23"/>
+                <a:baseline val="-25000"/>
+              </a:rPr>
+              <a:t>C</a:t>
+            </a:r>
+            <a:r>
+              <a:rPr sz="2200" b="1">
+                <a:solidFill>
+                  <a:srgbClr val="5234B7"/>
+                </a:solidFill>
+                <a:latin typeface="DIN Next LT W23"/>
+                <a:ea typeface="DIN Next LT W23"/>
+                <a:cs typeface="DIN Next LT W23"/>
+              </a:rPr>
+              <a:t> ≈ 7.6</a:t>
             </a:r>
           </a:p>
         </p:txBody>

</xml_diff>

<commit_message>
feat: refine formula rendering in PowerPoint generation by improving layout and adding support for stacked fractions, enhancing educational clarity
</commit_message>
<xml_diff>
--- a/web-presentation/pdf-exports/Week1-Session1-Foundations.pptx
+++ b/web-presentation/pdf-exports/Week1-Session1-Foundations.pptx
@@ -10312,8 +10312,8 @@
         </p:nvSpPr>
         <p:spPr>
           <a:xfrm>
-            <a:off x="548640" y="2651760"/>
-            <a:ext cx="10972800" cy="1417320"/>
+            <a:off x="548640" y="2606040"/>
+            <a:ext cx="10972800" cy="1874519"/>
           </a:xfrm>
           <a:prstGeom prst="roundRect">
             <a:avLst>
@@ -10358,8 +10358,8 @@
         </p:nvSpPr>
         <p:spPr>
           <a:xfrm>
-            <a:off x="914400" y="2834640"/>
-            <a:ext cx="10241280" cy="274320"/>
+            <a:off x="914400" y="2697480"/>
+            <a:ext cx="10241280" cy="256032"/>
           </a:xfrm>
           <a:prstGeom prst="rect">
             <a:avLst/>
@@ -10395,285 +10395,115 @@
         </p:nvSpPr>
         <p:spPr>
           <a:xfrm>
-            <a:off x="914400" y="3154680"/>
-            <a:ext cx="10241280" cy="411480"/>
-          </a:xfrm>
-          <a:prstGeom prst="rect">
-            <a:avLst/>
-          </a:prstGeom>
-          <a:noFill/>
-        </p:spPr>
-        <p:txBody>
-          <a:bodyPr wrap="square" anchor="t">
-            <a:spAutoFit/>
-          </a:bodyPr>
-          <a:lstStyle/>
-          <a:p>
-            <a:pPr algn="l"/>
-            <a:r>
-              <a:rPr sz="2200" b="1">
+            <a:off x="914400" y="2971800"/>
+            <a:ext cx="2867558" cy="1097280"/>
+          </a:xfrm>
+          <a:prstGeom prst="rect">
+            <a:avLst/>
+          </a:prstGeom>
+          <a:noFill/>
+        </p:spPr>
+        <p:txBody>
+          <a:bodyPr wrap="none" anchor="ctr">
+            <a:spAutoFit/>
+          </a:bodyPr>
+          <a:lstStyle/>
+          <a:p>
+            <a:pPr algn="r"/>
+            <a:r>
+              <a:rPr sz="2400" b="1">
                 <a:solidFill>
                   <a:srgbClr val="5234B7"/>
                 </a:solidFill>
-                <a:latin typeface="DIN Next LT W23"/>
-                <a:ea typeface="DIN Next LT W23"/>
-                <a:cs typeface="DIN Next LT W23"/>
+                <a:latin typeface="Helvetica Neue"/>
+                <a:ea typeface="Helvetica Neue"/>
+                <a:cs typeface="Helvetica Neue"/>
               </a:rPr>
               <a:t>x</a:t>
             </a:r>
             <a:r>
-              <a:rPr sz="1600" b="1">
+              <a:rPr sz="2000" b="1" baseline="-25000">
                 <a:solidFill>
                   <a:srgbClr val="5234B7"/>
                 </a:solidFill>
-                <a:latin typeface="DIN Next LT W23"/>
-                <a:ea typeface="DIN Next LT W23"/>
-                <a:cs typeface="DIN Next LT W23"/>
-                <a:baseline val="-25000"/>
+                <a:latin typeface="Helvetica Neue"/>
+                <a:ea typeface="Helvetica Neue"/>
+                <a:cs typeface="Helvetica Neue"/>
               </a:rPr>
               <a:t>norm</a:t>
             </a:r>
             <a:r>
-              <a:rPr sz="2200" b="1">
+              <a:rPr sz="2400" b="1">
                 <a:solidFill>
                   <a:srgbClr val="5234B7"/>
                 </a:solidFill>
-                <a:latin typeface="DIN Next LT W23"/>
-                <a:ea typeface="DIN Next LT W23"/>
-                <a:cs typeface="DIN Next LT W23"/>
-              </a:rPr>
-              <a:t> = (x − x</a:t>
-            </a:r>
-            <a:r>
-              <a:rPr sz="1600" b="1">
+                <a:latin typeface="Helvetica Neue"/>
+                <a:ea typeface="Helvetica Neue"/>
+                <a:cs typeface="Helvetica Neue"/>
+              </a:rPr>
+              <a:t> =</a:t>
+            </a:r>
+          </a:p>
+        </p:txBody>
+      </p:sp>
+      <p:sp>
+        <p:nvSpPr>
+          <p:cNvPr id="12" name="TextBox 11"/>
+          <p:cNvSpPr txBox="1"/>
+          <p:nvPr/>
+        </p:nvSpPr>
+        <p:spPr>
+          <a:xfrm>
+            <a:off x="3986784" y="2971800"/>
+            <a:ext cx="6964070" cy="416966"/>
+          </a:xfrm>
+          <a:prstGeom prst="rect">
+            <a:avLst/>
+          </a:prstGeom>
+          <a:noFill/>
+        </p:spPr>
+        <p:txBody>
+          <a:bodyPr wrap="none" anchor="b">
+            <a:spAutoFit/>
+          </a:bodyPr>
+          <a:lstStyle/>
+          <a:p>
+            <a:pPr algn="ctr"/>
+            <a:r>
+              <a:rPr sz="2400" b="1">
                 <a:solidFill>
                   <a:srgbClr val="5234B7"/>
                 </a:solidFill>
-                <a:latin typeface="DIN Next LT W23"/>
-                <a:ea typeface="DIN Next LT W23"/>
-                <a:cs typeface="DIN Next LT W23"/>
-                <a:baseline val="-25000"/>
+                <a:latin typeface="Helvetica Neue"/>
+                <a:ea typeface="Helvetica Neue"/>
+                <a:cs typeface="Helvetica Neue"/>
+              </a:rPr>
+              <a:t>x − x</a:t>
+            </a:r>
+            <a:r>
+              <a:rPr sz="2000" b="1" baseline="-25000">
+                <a:solidFill>
+                  <a:srgbClr val="5234B7"/>
+                </a:solidFill>
+                <a:latin typeface="Helvetica Neue"/>
+                <a:ea typeface="Helvetica Neue"/>
+                <a:cs typeface="Helvetica Neue"/>
               </a:rPr>
               <a:t>min</a:t>
             </a:r>
-            <a:r>
-              <a:rPr sz="2200" b="1">
-                <a:solidFill>
-                  <a:srgbClr val="5234B7"/>
-                </a:solidFill>
-                <a:latin typeface="DIN Next LT W23"/>
-                <a:ea typeface="DIN Next LT W23"/>
-                <a:cs typeface="DIN Next LT W23"/>
-              </a:rPr>
-              <a:t>) / (x</a:t>
-            </a:r>
-            <a:r>
-              <a:rPr sz="1600" b="1">
-                <a:solidFill>
-                  <a:srgbClr val="5234B7"/>
-                </a:solidFill>
-                <a:latin typeface="DIN Next LT W23"/>
-                <a:ea typeface="DIN Next LT W23"/>
-                <a:cs typeface="DIN Next LT W23"/>
-                <a:baseline val="-25000"/>
-              </a:rPr>
-              <a:t>max</a:t>
-            </a:r>
-            <a:r>
-              <a:rPr sz="2200" b="1">
-                <a:solidFill>
-                  <a:srgbClr val="5234B7"/>
-                </a:solidFill>
-                <a:latin typeface="DIN Next LT W23"/>
-                <a:ea typeface="DIN Next LT W23"/>
-                <a:cs typeface="DIN Next LT W23"/>
-              </a:rPr>
-              <a:t> − x</a:t>
-            </a:r>
-            <a:r>
-              <a:rPr sz="1600" b="1">
-                <a:solidFill>
-                  <a:srgbClr val="5234B7"/>
-                </a:solidFill>
-                <a:latin typeface="DIN Next LT W23"/>
-                <a:ea typeface="DIN Next LT W23"/>
-                <a:cs typeface="DIN Next LT W23"/>
-                <a:baseline val="-25000"/>
-              </a:rPr>
-              <a:t>min</a:t>
-            </a:r>
-            <a:r>
-              <a:rPr sz="2200" b="1">
-                <a:solidFill>
-                  <a:srgbClr val="5234B7"/>
-                </a:solidFill>
-                <a:latin typeface="DIN Next LT W23"/>
-                <a:ea typeface="DIN Next LT W23"/>
-                <a:cs typeface="DIN Next LT W23"/>
-              </a:rPr>
-              <a:t>)</a:t>
-            </a:r>
-          </a:p>
-        </p:txBody>
-      </p:sp>
-      <p:sp>
-        <p:nvSpPr>
-          <p:cNvPr id="12" name="TextBox 11"/>
-          <p:cNvSpPr txBox="1"/>
-          <p:nvPr/>
-        </p:nvSpPr>
-        <p:spPr>
-          <a:xfrm>
-            <a:off x="548640" y="4343400"/>
-            <a:ext cx="320040" cy="365760"/>
-          </a:xfrm>
-          <a:prstGeom prst="rect">
-            <a:avLst/>
-          </a:prstGeom>
-          <a:noFill/>
-        </p:spPr>
-        <p:txBody>
-          <a:bodyPr wrap="square" anchor="t">
-            <a:spAutoFit/>
-          </a:bodyPr>
-          <a:lstStyle/>
-          <a:p>
-            <a:pPr algn="l"/>
-            <a:r>
-              <a:rPr sz="1600" b="0">
-                <a:solidFill>
-                  <a:srgbClr val="9E59CD"/>
-                </a:solidFill>
-                <a:latin typeface="DIN Next LT W23"/>
-                <a:ea typeface="DIN Next LT W23"/>
-                <a:cs typeface="DIN Next LT W23"/>
-              </a:rPr>
-              <a:t>–</a:t>
-            </a:r>
-          </a:p>
-        </p:txBody>
-      </p:sp>
-      <p:sp>
-        <p:nvSpPr>
-          <p:cNvPr id="13" name="TextBox 12"/>
-          <p:cNvSpPr txBox="1"/>
-          <p:nvPr/>
-        </p:nvSpPr>
-        <p:spPr>
-          <a:xfrm>
-            <a:off x="914400" y="4343400"/>
-            <a:ext cx="10241280" cy="411480"/>
-          </a:xfrm>
-          <a:prstGeom prst="rect">
-            <a:avLst/>
-          </a:prstGeom>
-          <a:noFill/>
-        </p:spPr>
-        <p:txBody>
-          <a:bodyPr wrap="square" anchor="t">
-            <a:spAutoFit/>
-          </a:bodyPr>
-          <a:lstStyle/>
-          <a:p>
-            <a:pPr algn="l"/>
-            <a:r>
-              <a:rPr sz="1600" b="0">
-                <a:solidFill>
-                  <a:srgbClr val="121018"/>
-                </a:solidFill>
-                <a:latin typeface="DIN Next LT W23"/>
-                <a:ea typeface="DIN Next LT W23"/>
-                <a:cs typeface="DIN Next LT W23"/>
-              </a:rPr>
-              <a:t>Useful for models that depend on distances or absolute magnitudes.</a:t>
-            </a:r>
-          </a:p>
-        </p:txBody>
-      </p:sp>
-      <p:sp>
-        <p:nvSpPr>
-          <p:cNvPr id="14" name="TextBox 13"/>
-          <p:cNvSpPr txBox="1"/>
-          <p:nvPr/>
-        </p:nvSpPr>
-        <p:spPr>
-          <a:xfrm>
-            <a:off x="548640" y="4965192"/>
-            <a:ext cx="320040" cy="365760"/>
-          </a:xfrm>
-          <a:prstGeom prst="rect">
-            <a:avLst/>
-          </a:prstGeom>
-          <a:noFill/>
-        </p:spPr>
-        <p:txBody>
-          <a:bodyPr wrap="square" anchor="t">
-            <a:spAutoFit/>
-          </a:bodyPr>
-          <a:lstStyle/>
-          <a:p>
-            <a:pPr algn="l"/>
-            <a:r>
-              <a:rPr sz="1600" b="0">
-                <a:solidFill>
-                  <a:srgbClr val="9E59CD"/>
-                </a:solidFill>
-                <a:latin typeface="DIN Next LT W23"/>
-                <a:ea typeface="DIN Next LT W23"/>
-                <a:cs typeface="DIN Next LT W23"/>
-              </a:rPr>
-              <a:t>–</a:t>
-            </a:r>
-          </a:p>
-        </p:txBody>
-      </p:sp>
-      <p:sp>
-        <p:nvSpPr>
-          <p:cNvPr id="15" name="TextBox 14"/>
-          <p:cNvSpPr txBox="1"/>
-          <p:nvPr/>
-        </p:nvSpPr>
-        <p:spPr>
-          <a:xfrm>
-            <a:off x="914400" y="4965192"/>
-            <a:ext cx="10241280" cy="411480"/>
-          </a:xfrm>
-          <a:prstGeom prst="rect">
-            <a:avLst/>
-          </a:prstGeom>
-          <a:noFill/>
-        </p:spPr>
-        <p:txBody>
-          <a:bodyPr wrap="square" anchor="t">
-            <a:spAutoFit/>
-          </a:bodyPr>
-          <a:lstStyle/>
-          <a:p>
-            <a:pPr algn="l"/>
-            <a:r>
-              <a:rPr sz="1600" b="0">
-                <a:solidFill>
-                  <a:srgbClr val="121018"/>
-                </a:solidFill>
-                <a:latin typeface="DIN Next LT W23"/>
-                <a:ea typeface="DIN Next LT W23"/>
-                <a:cs typeface="DIN Next LT W23"/>
-              </a:rPr>
-              <a:t>Common choice for algorithms such as KNN and K-Means.</a:t>
-            </a:r>
-          </a:p>
-        </p:txBody>
-      </p:sp>
-      <p:sp>
-        <p:nvSpPr>
-          <p:cNvPr id="16" name="Rectangle 15"/>
+          </a:p>
+        </p:txBody>
+      </p:sp>
+      <p:sp>
+        <p:nvSpPr>
+          <p:cNvPr id="13" name="Rectangle 12"/>
           <p:cNvSpPr/>
           <p:nvPr/>
         </p:nvSpPr>
         <p:spPr>
           <a:xfrm>
-            <a:off x="548640" y="6446520"/>
-            <a:ext cx="11064240" cy="10972"/>
+            <a:off x="4334987" y="3434852"/>
+            <a:ext cx="6267663" cy="18288"/>
           </a:xfrm>
           <a:prstGeom prst="rect">
             <a:avLst/>
@@ -10710,7 +10540,269 @@
       </p:sp>
       <p:sp>
         <p:nvSpPr>
+          <p:cNvPr id="14" name="TextBox 13"/>
+          <p:cNvSpPr txBox="1"/>
+          <p:nvPr/>
+        </p:nvSpPr>
+        <p:spPr>
+          <a:xfrm>
+            <a:off x="3986784" y="3520440"/>
+            <a:ext cx="6964070" cy="416966"/>
+          </a:xfrm>
+          <a:prstGeom prst="rect">
+            <a:avLst/>
+          </a:prstGeom>
+          <a:noFill/>
+        </p:spPr>
+        <p:txBody>
+          <a:bodyPr wrap="none" anchor="t">
+            <a:spAutoFit/>
+          </a:bodyPr>
+          <a:lstStyle/>
+          <a:p>
+            <a:pPr algn="ctr"/>
+            <a:r>
+              <a:rPr sz="2400" b="1">
+                <a:solidFill>
+                  <a:srgbClr val="5234B7"/>
+                </a:solidFill>
+                <a:latin typeface="Helvetica Neue"/>
+                <a:ea typeface="Helvetica Neue"/>
+                <a:cs typeface="Helvetica Neue"/>
+              </a:rPr>
+              <a:t>x</a:t>
+            </a:r>
+            <a:r>
+              <a:rPr sz="2000" b="1" baseline="-25000">
+                <a:solidFill>
+                  <a:srgbClr val="5234B7"/>
+                </a:solidFill>
+                <a:latin typeface="Helvetica Neue"/>
+                <a:ea typeface="Helvetica Neue"/>
+                <a:cs typeface="Helvetica Neue"/>
+              </a:rPr>
+              <a:t>max</a:t>
+            </a:r>
+            <a:r>
+              <a:rPr sz="2400" b="1">
+                <a:solidFill>
+                  <a:srgbClr val="5234B7"/>
+                </a:solidFill>
+                <a:latin typeface="Helvetica Neue"/>
+                <a:ea typeface="Helvetica Neue"/>
+                <a:cs typeface="Helvetica Neue"/>
+              </a:rPr>
+              <a:t> − x</a:t>
+            </a:r>
+            <a:r>
+              <a:rPr sz="2000" b="1" baseline="-25000">
+                <a:solidFill>
+                  <a:srgbClr val="5234B7"/>
+                </a:solidFill>
+                <a:latin typeface="Helvetica Neue"/>
+                <a:ea typeface="Helvetica Neue"/>
+                <a:cs typeface="Helvetica Neue"/>
+              </a:rPr>
+              <a:t>min</a:t>
+            </a:r>
+          </a:p>
+        </p:txBody>
+      </p:sp>
+      <p:sp>
+        <p:nvSpPr>
+          <p:cNvPr id="15" name="TextBox 14"/>
+          <p:cNvSpPr txBox="1"/>
+          <p:nvPr/>
+        </p:nvSpPr>
+        <p:spPr>
+          <a:xfrm>
+            <a:off x="548640" y="4709160"/>
+            <a:ext cx="320040" cy="365760"/>
+          </a:xfrm>
+          <a:prstGeom prst="rect">
+            <a:avLst/>
+          </a:prstGeom>
+          <a:noFill/>
+        </p:spPr>
+        <p:txBody>
+          <a:bodyPr wrap="square" anchor="t">
+            <a:spAutoFit/>
+          </a:bodyPr>
+          <a:lstStyle/>
+          <a:p>
+            <a:pPr algn="l"/>
+            <a:r>
+              <a:rPr sz="1600" b="0">
+                <a:solidFill>
+                  <a:srgbClr val="9E59CD"/>
+                </a:solidFill>
+                <a:latin typeface="DIN Next LT W23"/>
+                <a:ea typeface="DIN Next LT W23"/>
+                <a:cs typeface="DIN Next LT W23"/>
+              </a:rPr>
+              <a:t>–</a:t>
+            </a:r>
+          </a:p>
+        </p:txBody>
+      </p:sp>
+      <p:sp>
+        <p:nvSpPr>
+          <p:cNvPr id="16" name="TextBox 15"/>
+          <p:cNvSpPr txBox="1"/>
+          <p:nvPr/>
+        </p:nvSpPr>
+        <p:spPr>
+          <a:xfrm>
+            <a:off x="914400" y="4709160"/>
+            <a:ext cx="10241280" cy="411480"/>
+          </a:xfrm>
+          <a:prstGeom prst="rect">
+            <a:avLst/>
+          </a:prstGeom>
+          <a:noFill/>
+        </p:spPr>
+        <p:txBody>
+          <a:bodyPr wrap="square" anchor="t">
+            <a:spAutoFit/>
+          </a:bodyPr>
+          <a:lstStyle/>
+          <a:p>
+            <a:pPr algn="l"/>
+            <a:r>
+              <a:rPr sz="1600" b="0">
+                <a:solidFill>
+                  <a:srgbClr val="121018"/>
+                </a:solidFill>
+                <a:latin typeface="DIN Next LT W23"/>
+                <a:ea typeface="DIN Next LT W23"/>
+                <a:cs typeface="DIN Next LT W23"/>
+              </a:rPr>
+              <a:t>Useful for models that depend on distances or absolute magnitudes.</a:t>
+            </a:r>
+          </a:p>
+        </p:txBody>
+      </p:sp>
+      <p:sp>
+        <p:nvSpPr>
           <p:cNvPr id="17" name="TextBox 16"/>
+          <p:cNvSpPr txBox="1"/>
+          <p:nvPr/>
+        </p:nvSpPr>
+        <p:spPr>
+          <a:xfrm>
+            <a:off x="548640" y="5330952"/>
+            <a:ext cx="320040" cy="365760"/>
+          </a:xfrm>
+          <a:prstGeom prst="rect">
+            <a:avLst/>
+          </a:prstGeom>
+          <a:noFill/>
+        </p:spPr>
+        <p:txBody>
+          <a:bodyPr wrap="square" anchor="t">
+            <a:spAutoFit/>
+          </a:bodyPr>
+          <a:lstStyle/>
+          <a:p>
+            <a:pPr algn="l"/>
+            <a:r>
+              <a:rPr sz="1600" b="0">
+                <a:solidFill>
+                  <a:srgbClr val="9E59CD"/>
+                </a:solidFill>
+                <a:latin typeface="DIN Next LT W23"/>
+                <a:ea typeface="DIN Next LT W23"/>
+                <a:cs typeface="DIN Next LT W23"/>
+              </a:rPr>
+              <a:t>–</a:t>
+            </a:r>
+          </a:p>
+        </p:txBody>
+      </p:sp>
+      <p:sp>
+        <p:nvSpPr>
+          <p:cNvPr id="18" name="TextBox 17"/>
+          <p:cNvSpPr txBox="1"/>
+          <p:nvPr/>
+        </p:nvSpPr>
+        <p:spPr>
+          <a:xfrm>
+            <a:off x="914400" y="5330952"/>
+            <a:ext cx="10241280" cy="411480"/>
+          </a:xfrm>
+          <a:prstGeom prst="rect">
+            <a:avLst/>
+          </a:prstGeom>
+          <a:noFill/>
+        </p:spPr>
+        <p:txBody>
+          <a:bodyPr wrap="square" anchor="t">
+            <a:spAutoFit/>
+          </a:bodyPr>
+          <a:lstStyle/>
+          <a:p>
+            <a:pPr algn="l"/>
+            <a:r>
+              <a:rPr sz="1600" b="0">
+                <a:solidFill>
+                  <a:srgbClr val="121018"/>
+                </a:solidFill>
+                <a:latin typeface="DIN Next LT W23"/>
+                <a:ea typeface="DIN Next LT W23"/>
+                <a:cs typeface="DIN Next LT W23"/>
+              </a:rPr>
+              <a:t>Common choice for algorithms such as KNN and K-Means.</a:t>
+            </a:r>
+          </a:p>
+        </p:txBody>
+      </p:sp>
+      <p:sp>
+        <p:nvSpPr>
+          <p:cNvPr id="19" name="Rectangle 18"/>
+          <p:cNvSpPr/>
+          <p:nvPr/>
+        </p:nvSpPr>
+        <p:spPr>
+          <a:xfrm>
+            <a:off x="548640" y="6446520"/>
+            <a:ext cx="11064240" cy="10972"/>
+          </a:xfrm>
+          <a:prstGeom prst="rect">
+            <a:avLst/>
+          </a:prstGeom>
+          <a:solidFill>
+            <a:srgbClr val="5234B7"/>
+          </a:solidFill>
+          <a:ln>
+            <a:noFill/>
+          </a:ln>
+          <a:effectLst/>
+        </p:spPr>
+        <p:style>
+          <a:lnRef idx="1">
+            <a:schemeClr val="accent1"/>
+          </a:lnRef>
+          <a:fillRef idx="3">
+            <a:schemeClr val="accent1"/>
+          </a:fillRef>
+          <a:effectRef idx="2">
+            <a:schemeClr val="accent1"/>
+          </a:effectRef>
+          <a:fontRef idx="minor">
+            <a:schemeClr val="lt1"/>
+          </a:fontRef>
+        </p:style>
+        <p:txBody>
+          <a:bodyPr rtlCol="0" anchor="ctr"/>
+          <a:lstStyle/>
+          <a:p>
+            <a:pPr algn="ctr"/>
+          </a:p>
+        </p:txBody>
+      </p:sp>
+      <p:sp>
+        <p:nvSpPr>
+          <p:cNvPr id="20" name="TextBox 19"/>
           <p:cNvSpPr txBox="1"/>
           <p:nvPr/>
         </p:nvSpPr>
@@ -10747,7 +10839,7 @@
       </p:sp>
       <p:sp>
         <p:nvSpPr>
-          <p:cNvPr id="18" name="TextBox 17"/>
+          <p:cNvPr id="21" name="TextBox 20"/>
           <p:cNvSpPr txBox="1"/>
           <p:nvPr/>
         </p:nvSpPr>
@@ -11076,8 +11168,8 @@
         </p:nvSpPr>
         <p:spPr>
           <a:xfrm>
-            <a:off x="548640" y="2651760"/>
-            <a:ext cx="10972800" cy="1417320"/>
+            <a:off x="548640" y="2606040"/>
+            <a:ext cx="10972800" cy="1874519"/>
           </a:xfrm>
           <a:prstGeom prst="roundRect">
             <a:avLst>
@@ -11122,8 +11214,8 @@
         </p:nvSpPr>
         <p:spPr>
           <a:xfrm>
-            <a:off x="914400" y="2834640"/>
-            <a:ext cx="10241280" cy="274320"/>
+            <a:off x="914400" y="2697480"/>
+            <a:ext cx="10241280" cy="256032"/>
           </a:xfrm>
           <a:prstGeom prst="rect">
             <a:avLst/>
@@ -11159,31 +11251,31 @@
         </p:nvSpPr>
         <p:spPr>
           <a:xfrm>
-            <a:off x="914400" y="3154680"/>
-            <a:ext cx="10241280" cy="411480"/>
-          </a:xfrm>
-          <a:prstGeom prst="rect">
-            <a:avLst/>
-          </a:prstGeom>
-          <a:noFill/>
-        </p:spPr>
-        <p:txBody>
-          <a:bodyPr wrap="square" anchor="t">
-            <a:spAutoFit/>
-          </a:bodyPr>
-          <a:lstStyle/>
-          <a:p>
-            <a:pPr algn="l"/>
-            <a:r>
-              <a:rPr sz="2200" b="1">
+            <a:off x="914400" y="2971800"/>
+            <a:ext cx="2867558" cy="1097280"/>
+          </a:xfrm>
+          <a:prstGeom prst="rect">
+            <a:avLst/>
+          </a:prstGeom>
+          <a:noFill/>
+        </p:spPr>
+        <p:txBody>
+          <a:bodyPr wrap="none" anchor="ctr">
+            <a:spAutoFit/>
+          </a:bodyPr>
+          <a:lstStyle/>
+          <a:p>
+            <a:pPr algn="r"/>
+            <a:r>
+              <a:rPr sz="2400" b="1">
                 <a:solidFill>
                   <a:srgbClr val="5234B7"/>
                 </a:solidFill>
-                <a:latin typeface="DIN Next LT W23"/>
-                <a:ea typeface="DIN Next LT W23"/>
-                <a:cs typeface="DIN Next LT W23"/>
-              </a:rPr>
-              <a:t>z = (x − μ) / σ</a:t>
+                <a:latin typeface="Helvetica Neue"/>
+                <a:ea typeface="Helvetica Neue"/>
+                <a:cs typeface="Helvetica Neue"/>
+              </a:rPr>
+              <a:t>z =</a:t>
             </a:r>
           </a:p>
         </p:txBody>
@@ -11196,193 +11288,45 @@
         </p:nvSpPr>
         <p:spPr>
           <a:xfrm>
-            <a:off x="914400" y="3611880"/>
-            <a:ext cx="10241280" cy="274320"/>
-          </a:xfrm>
-          <a:prstGeom prst="rect">
-            <a:avLst/>
-          </a:prstGeom>
-          <a:noFill/>
-        </p:spPr>
-        <p:txBody>
-          <a:bodyPr wrap="square" anchor="t">
-            <a:spAutoFit/>
-          </a:bodyPr>
-          <a:lstStyle/>
-          <a:p>
-            <a:pPr algn="l"/>
-            <a:r>
-              <a:rPr sz="1300" b="0">
-                <a:solidFill>
-                  <a:srgbClr val="5A5470"/>
-                </a:solidFill>
-                <a:latin typeface="DIN Next LT W23"/>
-                <a:ea typeface="DIN Next LT W23"/>
-                <a:cs typeface="DIN Next LT W23"/>
-              </a:rPr>
-              <a:t>μ = mean of the feature · σ = standard deviation of the feature</a:t>
-            </a:r>
-          </a:p>
-        </p:txBody>
-      </p:sp>
-      <p:sp>
-        <p:nvSpPr>
-          <p:cNvPr id="13" name="TextBox 12"/>
-          <p:cNvSpPr txBox="1"/>
-          <p:nvPr/>
-        </p:nvSpPr>
-        <p:spPr>
-          <a:xfrm>
-            <a:off x="548640" y="4343400"/>
-            <a:ext cx="320040" cy="365760"/>
-          </a:xfrm>
-          <a:prstGeom prst="rect">
-            <a:avLst/>
-          </a:prstGeom>
-          <a:noFill/>
-        </p:spPr>
-        <p:txBody>
-          <a:bodyPr wrap="square" anchor="t">
-            <a:spAutoFit/>
-          </a:bodyPr>
-          <a:lstStyle/>
-          <a:p>
-            <a:pPr algn="l"/>
-            <a:r>
-              <a:rPr sz="1600" b="0">
-                <a:solidFill>
-                  <a:srgbClr val="9E59CD"/>
-                </a:solidFill>
-                <a:latin typeface="DIN Next LT W23"/>
-                <a:ea typeface="DIN Next LT W23"/>
-                <a:cs typeface="DIN Next LT W23"/>
-              </a:rPr>
-              <a:t>–</a:t>
-            </a:r>
-          </a:p>
-        </p:txBody>
-      </p:sp>
-      <p:sp>
-        <p:nvSpPr>
-          <p:cNvPr id="14" name="TextBox 13"/>
-          <p:cNvSpPr txBox="1"/>
-          <p:nvPr/>
-        </p:nvSpPr>
-        <p:spPr>
-          <a:xfrm>
-            <a:off x="914400" y="4343400"/>
-            <a:ext cx="10241280" cy="411480"/>
-          </a:xfrm>
-          <a:prstGeom prst="rect">
-            <a:avLst/>
-          </a:prstGeom>
-          <a:noFill/>
-        </p:spPr>
-        <p:txBody>
-          <a:bodyPr wrap="square" anchor="t">
-            <a:spAutoFit/>
-          </a:bodyPr>
-          <a:lstStyle/>
-          <a:p>
-            <a:pPr algn="l"/>
-            <a:r>
-              <a:rPr sz="1600" b="0">
-                <a:solidFill>
-                  <a:srgbClr val="121018"/>
-                </a:solidFill>
-                <a:latin typeface="DIN Next LT W23"/>
-                <a:ea typeface="DIN Next LT W23"/>
-                <a:cs typeface="DIN Next LT W23"/>
-              </a:rPr>
-              <a:t>Preferred when features are close to a Gaussian distribution.</a:t>
-            </a:r>
-          </a:p>
-        </p:txBody>
-      </p:sp>
-      <p:sp>
-        <p:nvSpPr>
-          <p:cNvPr id="15" name="TextBox 14"/>
-          <p:cNvSpPr txBox="1"/>
-          <p:nvPr/>
-        </p:nvSpPr>
-        <p:spPr>
-          <a:xfrm>
-            <a:off x="548640" y="4965192"/>
-            <a:ext cx="320040" cy="365760"/>
-          </a:xfrm>
-          <a:prstGeom prst="rect">
-            <a:avLst/>
-          </a:prstGeom>
-          <a:noFill/>
-        </p:spPr>
-        <p:txBody>
-          <a:bodyPr wrap="square" anchor="t">
-            <a:spAutoFit/>
-          </a:bodyPr>
-          <a:lstStyle/>
-          <a:p>
-            <a:pPr algn="l"/>
-            <a:r>
-              <a:rPr sz="1600" b="0">
-                <a:solidFill>
-                  <a:srgbClr val="9E59CD"/>
-                </a:solidFill>
-                <a:latin typeface="DIN Next LT W23"/>
-                <a:ea typeface="DIN Next LT W23"/>
-                <a:cs typeface="DIN Next LT W23"/>
-              </a:rPr>
-              <a:t>–</a:t>
-            </a:r>
-          </a:p>
-        </p:txBody>
-      </p:sp>
-      <p:sp>
-        <p:nvSpPr>
-          <p:cNvPr id="16" name="TextBox 15"/>
-          <p:cNvSpPr txBox="1"/>
-          <p:nvPr/>
-        </p:nvSpPr>
-        <p:spPr>
-          <a:xfrm>
-            <a:off x="914400" y="4965192"/>
-            <a:ext cx="10241280" cy="411480"/>
-          </a:xfrm>
-          <a:prstGeom prst="rect">
-            <a:avLst/>
-          </a:prstGeom>
-          <a:noFill/>
-        </p:spPr>
-        <p:txBody>
-          <a:bodyPr wrap="square" anchor="t">
-            <a:spAutoFit/>
-          </a:bodyPr>
-          <a:lstStyle/>
-          <a:p>
-            <a:pPr algn="l"/>
-            <a:r>
-              <a:rPr sz="1600" b="0">
-                <a:solidFill>
-                  <a:srgbClr val="121018"/>
-                </a:solidFill>
-                <a:latin typeface="DIN Next LT W23"/>
-                <a:ea typeface="DIN Next LT W23"/>
-                <a:cs typeface="DIN Next LT W23"/>
-              </a:rPr>
-              <a:t>Works well with Logistic Regression, SVM, and Linear Regression.</a:t>
-            </a:r>
-          </a:p>
-        </p:txBody>
-      </p:sp>
-      <p:sp>
-        <p:nvSpPr>
-          <p:cNvPr id="17" name="Rectangle 16"/>
+            <a:off x="3986784" y="2971800"/>
+            <a:ext cx="6964070" cy="416966"/>
+          </a:xfrm>
+          <a:prstGeom prst="rect">
+            <a:avLst/>
+          </a:prstGeom>
+          <a:noFill/>
+        </p:spPr>
+        <p:txBody>
+          <a:bodyPr wrap="none" anchor="b">
+            <a:spAutoFit/>
+          </a:bodyPr>
+          <a:lstStyle/>
+          <a:p>
+            <a:pPr algn="ctr"/>
+            <a:r>
+              <a:rPr sz="2400" b="1">
+                <a:solidFill>
+                  <a:srgbClr val="5234B7"/>
+                </a:solidFill>
+                <a:latin typeface="Helvetica Neue"/>
+                <a:ea typeface="Helvetica Neue"/>
+                <a:cs typeface="Helvetica Neue"/>
+              </a:rPr>
+              <a:t>x − μ</a:t>
+            </a:r>
+          </a:p>
+        </p:txBody>
+      </p:sp>
+      <p:sp>
+        <p:nvSpPr>
+          <p:cNvPr id="13" name="Rectangle 12"/>
           <p:cNvSpPr/>
           <p:nvPr/>
         </p:nvSpPr>
         <p:spPr>
           <a:xfrm>
-            <a:off x="548640" y="6446520"/>
-            <a:ext cx="11064240" cy="10972"/>
+            <a:off x="4334987" y="3434852"/>
+            <a:ext cx="6267663" cy="18288"/>
           </a:xfrm>
           <a:prstGeom prst="rect">
             <a:avLst/>
@@ -11419,7 +11363,273 @@
       </p:sp>
       <p:sp>
         <p:nvSpPr>
+          <p:cNvPr id="14" name="TextBox 13"/>
+          <p:cNvSpPr txBox="1"/>
+          <p:nvPr/>
+        </p:nvSpPr>
+        <p:spPr>
+          <a:xfrm>
+            <a:off x="3986784" y="3520440"/>
+            <a:ext cx="6964070" cy="416966"/>
+          </a:xfrm>
+          <a:prstGeom prst="rect">
+            <a:avLst/>
+          </a:prstGeom>
+          <a:noFill/>
+        </p:spPr>
+        <p:txBody>
+          <a:bodyPr wrap="none" anchor="t">
+            <a:spAutoFit/>
+          </a:bodyPr>
+          <a:lstStyle/>
+          <a:p>
+            <a:pPr algn="ctr"/>
+            <a:r>
+              <a:rPr sz="2400" b="1">
+                <a:solidFill>
+                  <a:srgbClr val="5234B7"/>
+                </a:solidFill>
+                <a:latin typeface="Helvetica Neue"/>
+                <a:ea typeface="Helvetica Neue"/>
+                <a:cs typeface="Helvetica Neue"/>
+              </a:rPr>
+              <a:t>σ</a:t>
+            </a:r>
+          </a:p>
+        </p:txBody>
+      </p:sp>
+      <p:sp>
+        <p:nvSpPr>
+          <p:cNvPr id="15" name="TextBox 14"/>
+          <p:cNvSpPr txBox="1"/>
+          <p:nvPr/>
+        </p:nvSpPr>
+        <p:spPr>
+          <a:xfrm>
+            <a:off x="914400" y="4114800"/>
+            <a:ext cx="10241280" cy="256032"/>
+          </a:xfrm>
+          <a:prstGeom prst="rect">
+            <a:avLst/>
+          </a:prstGeom>
+          <a:noFill/>
+        </p:spPr>
+        <p:txBody>
+          <a:bodyPr wrap="square" anchor="t">
+            <a:spAutoFit/>
+          </a:bodyPr>
+          <a:lstStyle/>
+          <a:p>
+            <a:pPr algn="l"/>
+            <a:r>
+              <a:rPr sz="1300" b="0">
+                <a:solidFill>
+                  <a:srgbClr val="5A5470"/>
+                </a:solidFill>
+                <a:latin typeface="Helvetica Neue"/>
+                <a:ea typeface="Helvetica Neue"/>
+                <a:cs typeface="Helvetica Neue"/>
+              </a:rPr>
+              <a:t>μ = mean of the feature · σ = standard deviation of the feature</a:t>
+            </a:r>
+          </a:p>
+        </p:txBody>
+      </p:sp>
+      <p:sp>
+        <p:nvSpPr>
+          <p:cNvPr id="16" name="TextBox 15"/>
+          <p:cNvSpPr txBox="1"/>
+          <p:nvPr/>
+        </p:nvSpPr>
+        <p:spPr>
+          <a:xfrm>
+            <a:off x="548640" y="4709160"/>
+            <a:ext cx="320040" cy="365760"/>
+          </a:xfrm>
+          <a:prstGeom prst="rect">
+            <a:avLst/>
+          </a:prstGeom>
+          <a:noFill/>
+        </p:spPr>
+        <p:txBody>
+          <a:bodyPr wrap="square" anchor="t">
+            <a:spAutoFit/>
+          </a:bodyPr>
+          <a:lstStyle/>
+          <a:p>
+            <a:pPr algn="l"/>
+            <a:r>
+              <a:rPr sz="1600" b="0">
+                <a:solidFill>
+                  <a:srgbClr val="9E59CD"/>
+                </a:solidFill>
+                <a:latin typeface="DIN Next LT W23"/>
+                <a:ea typeface="DIN Next LT W23"/>
+                <a:cs typeface="DIN Next LT W23"/>
+              </a:rPr>
+              <a:t>–</a:t>
+            </a:r>
+          </a:p>
+        </p:txBody>
+      </p:sp>
+      <p:sp>
+        <p:nvSpPr>
+          <p:cNvPr id="17" name="TextBox 16"/>
+          <p:cNvSpPr txBox="1"/>
+          <p:nvPr/>
+        </p:nvSpPr>
+        <p:spPr>
+          <a:xfrm>
+            <a:off x="914400" y="4709160"/>
+            <a:ext cx="10241280" cy="411480"/>
+          </a:xfrm>
+          <a:prstGeom prst="rect">
+            <a:avLst/>
+          </a:prstGeom>
+          <a:noFill/>
+        </p:spPr>
+        <p:txBody>
+          <a:bodyPr wrap="square" anchor="t">
+            <a:spAutoFit/>
+          </a:bodyPr>
+          <a:lstStyle/>
+          <a:p>
+            <a:pPr algn="l"/>
+            <a:r>
+              <a:rPr sz="1600" b="0">
+                <a:solidFill>
+                  <a:srgbClr val="121018"/>
+                </a:solidFill>
+                <a:latin typeface="DIN Next LT W23"/>
+                <a:ea typeface="DIN Next LT W23"/>
+                <a:cs typeface="DIN Next LT W23"/>
+              </a:rPr>
+              <a:t>Preferred when features are close to a Gaussian distribution.</a:t>
+            </a:r>
+          </a:p>
+        </p:txBody>
+      </p:sp>
+      <p:sp>
+        <p:nvSpPr>
           <p:cNvPr id="18" name="TextBox 17"/>
+          <p:cNvSpPr txBox="1"/>
+          <p:nvPr/>
+        </p:nvSpPr>
+        <p:spPr>
+          <a:xfrm>
+            <a:off x="548640" y="5330952"/>
+            <a:ext cx="320040" cy="365760"/>
+          </a:xfrm>
+          <a:prstGeom prst="rect">
+            <a:avLst/>
+          </a:prstGeom>
+          <a:noFill/>
+        </p:spPr>
+        <p:txBody>
+          <a:bodyPr wrap="square" anchor="t">
+            <a:spAutoFit/>
+          </a:bodyPr>
+          <a:lstStyle/>
+          <a:p>
+            <a:pPr algn="l"/>
+            <a:r>
+              <a:rPr sz="1600" b="0">
+                <a:solidFill>
+                  <a:srgbClr val="9E59CD"/>
+                </a:solidFill>
+                <a:latin typeface="DIN Next LT W23"/>
+                <a:ea typeface="DIN Next LT W23"/>
+                <a:cs typeface="DIN Next LT W23"/>
+              </a:rPr>
+              <a:t>–</a:t>
+            </a:r>
+          </a:p>
+        </p:txBody>
+      </p:sp>
+      <p:sp>
+        <p:nvSpPr>
+          <p:cNvPr id="19" name="TextBox 18"/>
+          <p:cNvSpPr txBox="1"/>
+          <p:nvPr/>
+        </p:nvSpPr>
+        <p:spPr>
+          <a:xfrm>
+            <a:off x="914400" y="5330952"/>
+            <a:ext cx="10241280" cy="411480"/>
+          </a:xfrm>
+          <a:prstGeom prst="rect">
+            <a:avLst/>
+          </a:prstGeom>
+          <a:noFill/>
+        </p:spPr>
+        <p:txBody>
+          <a:bodyPr wrap="square" anchor="t">
+            <a:spAutoFit/>
+          </a:bodyPr>
+          <a:lstStyle/>
+          <a:p>
+            <a:pPr algn="l"/>
+            <a:r>
+              <a:rPr sz="1600" b="0">
+                <a:solidFill>
+                  <a:srgbClr val="121018"/>
+                </a:solidFill>
+                <a:latin typeface="DIN Next LT W23"/>
+                <a:ea typeface="DIN Next LT W23"/>
+                <a:cs typeface="DIN Next LT W23"/>
+              </a:rPr>
+              <a:t>Works well with Logistic Regression, SVM, and Linear Regression.</a:t>
+            </a:r>
+          </a:p>
+        </p:txBody>
+      </p:sp>
+      <p:sp>
+        <p:nvSpPr>
+          <p:cNvPr id="20" name="Rectangle 19"/>
+          <p:cNvSpPr/>
+          <p:nvPr/>
+        </p:nvSpPr>
+        <p:spPr>
+          <a:xfrm>
+            <a:off x="548640" y="6446520"/>
+            <a:ext cx="11064240" cy="10972"/>
+          </a:xfrm>
+          <a:prstGeom prst="rect">
+            <a:avLst/>
+          </a:prstGeom>
+          <a:solidFill>
+            <a:srgbClr val="5234B7"/>
+          </a:solidFill>
+          <a:ln>
+            <a:noFill/>
+          </a:ln>
+          <a:effectLst/>
+        </p:spPr>
+        <p:style>
+          <a:lnRef idx="1">
+            <a:schemeClr val="accent1"/>
+          </a:lnRef>
+          <a:fillRef idx="3">
+            <a:schemeClr val="accent1"/>
+          </a:fillRef>
+          <a:effectRef idx="2">
+            <a:schemeClr val="accent1"/>
+          </a:effectRef>
+          <a:fontRef idx="minor">
+            <a:schemeClr val="lt1"/>
+          </a:fontRef>
+        </p:style>
+        <p:txBody>
+          <a:bodyPr rtlCol="0" anchor="ctr"/>
+          <a:lstStyle/>
+          <a:p>
+            <a:pPr algn="ctr"/>
+          </a:p>
+        </p:txBody>
+      </p:sp>
+      <p:sp>
+        <p:nvSpPr>
+          <p:cNvPr id="21" name="TextBox 20"/>
           <p:cNvSpPr txBox="1"/>
           <p:nvPr/>
         </p:nvSpPr>
@@ -11456,7 +11666,7 @@
       </p:sp>
       <p:sp>
         <p:nvSpPr>
-          <p:cNvPr id="19" name="TextBox 18"/>
+          <p:cNvPr id="22" name="TextBox 21"/>
           <p:cNvSpPr txBox="1"/>
           <p:nvPr/>
         </p:nvSpPr>
@@ -15445,8 +15655,8 @@
         </p:nvSpPr>
         <p:spPr>
           <a:xfrm>
-            <a:off x="548640" y="3611880"/>
-            <a:ext cx="10972800" cy="1051560"/>
+            <a:off x="548640" y="3246120"/>
+            <a:ext cx="10972800" cy="1417320"/>
           </a:xfrm>
           <a:prstGeom prst="roundRect">
             <a:avLst>
@@ -15491,204 +15701,294 @@
         </p:nvSpPr>
         <p:spPr>
           <a:xfrm>
-            <a:off x="868680" y="3749039"/>
-            <a:ext cx="10332720" cy="320040"/>
-          </a:xfrm>
-          <a:prstGeom prst="rect">
-            <a:avLst/>
-          </a:prstGeom>
-          <a:noFill/>
-        </p:spPr>
-        <p:txBody>
-          <a:bodyPr wrap="square" anchor="t">
-            <a:spAutoFit/>
-          </a:bodyPr>
-          <a:lstStyle/>
-          <a:p>
-            <a:pPr algn="l"/>
-            <a:r>
-              <a:rPr sz="1800" b="1">
+            <a:off x="868680" y="3337560"/>
+            <a:ext cx="2893161" cy="960120"/>
+          </a:xfrm>
+          <a:prstGeom prst="rect">
+            <a:avLst/>
+          </a:prstGeom>
+          <a:noFill/>
+        </p:spPr>
+        <p:txBody>
+          <a:bodyPr wrap="none" anchor="ctr">
+            <a:spAutoFit/>
+          </a:bodyPr>
+          <a:lstStyle/>
+          <a:p>
+            <a:pPr algn="r"/>
+            <a:r>
+              <a:rPr sz="2000" b="1">
                 <a:solidFill>
                   <a:srgbClr val="5234B7"/>
                 </a:solidFill>
-                <a:latin typeface="DIN Next LT W23"/>
-                <a:ea typeface="DIN Next LT W23"/>
-                <a:cs typeface="DIN Next LT W23"/>
+                <a:latin typeface="Helvetica Neue"/>
+                <a:ea typeface="Helvetica Neue"/>
+                <a:cs typeface="Helvetica Neue"/>
               </a:rPr>
               <a:t>x</a:t>
             </a:r>
             <a:r>
-              <a:rPr sz="1200" b="1">
+              <a:rPr sz="1600" b="1" baseline="-25000">
                 <a:solidFill>
                   <a:srgbClr val="5234B7"/>
                 </a:solidFill>
-                <a:latin typeface="DIN Next LT W23"/>
-                <a:ea typeface="DIN Next LT W23"/>
-                <a:cs typeface="DIN Next LT W23"/>
-                <a:baseline val="-25000"/>
+                <a:latin typeface="Helvetica Neue"/>
+                <a:ea typeface="Helvetica Neue"/>
+                <a:cs typeface="Helvetica Neue"/>
               </a:rPr>
               <a:t>norm</a:t>
             </a:r>
             <a:r>
-              <a:rPr sz="1800" b="1">
+              <a:rPr sz="2000" b="1">
                 <a:solidFill>
                   <a:srgbClr val="5234B7"/>
                 </a:solidFill>
-                <a:latin typeface="DIN Next LT W23"/>
-                <a:ea typeface="DIN Next LT W23"/>
-                <a:cs typeface="DIN Next LT W23"/>
-              </a:rPr>
-              <a:t> = (x − x</a:t>
-            </a:r>
-            <a:r>
-              <a:rPr sz="1200" b="1">
+                <a:latin typeface="Helvetica Neue"/>
+                <a:ea typeface="Helvetica Neue"/>
+                <a:cs typeface="Helvetica Neue"/>
+              </a:rPr>
+              <a:t> =</a:t>
+            </a:r>
+          </a:p>
+        </p:txBody>
+      </p:sp>
+      <p:sp>
+        <p:nvSpPr>
+          <p:cNvPr id="17" name="TextBox 16"/>
+          <p:cNvSpPr txBox="1"/>
+          <p:nvPr/>
+        </p:nvSpPr>
+        <p:spPr>
+          <a:xfrm>
+            <a:off x="3968496" y="3337560"/>
+            <a:ext cx="7026249" cy="364845"/>
+          </a:xfrm>
+          <a:prstGeom prst="rect">
+            <a:avLst/>
+          </a:prstGeom>
+          <a:noFill/>
+        </p:spPr>
+        <p:txBody>
+          <a:bodyPr wrap="none" anchor="b">
+            <a:spAutoFit/>
+          </a:bodyPr>
+          <a:lstStyle/>
+          <a:p>
+            <a:pPr algn="ctr"/>
+            <a:r>
+              <a:rPr sz="2000" b="1">
                 <a:solidFill>
                   <a:srgbClr val="5234B7"/>
                 </a:solidFill>
-                <a:latin typeface="DIN Next LT W23"/>
-                <a:ea typeface="DIN Next LT W23"/>
-                <a:cs typeface="DIN Next LT W23"/>
-                <a:baseline val="-25000"/>
+                <a:latin typeface="Helvetica Neue"/>
+                <a:ea typeface="Helvetica Neue"/>
+                <a:cs typeface="Helvetica Neue"/>
+              </a:rPr>
+              <a:t>x − x</a:t>
+            </a:r>
+            <a:r>
+              <a:rPr sz="1600" b="1" baseline="-25000">
+                <a:solidFill>
+                  <a:srgbClr val="5234B7"/>
+                </a:solidFill>
+                <a:latin typeface="Helvetica Neue"/>
+                <a:ea typeface="Helvetica Neue"/>
+                <a:cs typeface="Helvetica Neue"/>
               </a:rPr>
               <a:t>min</a:t>
             </a:r>
-            <a:r>
-              <a:rPr sz="1800" b="1">
+          </a:p>
+        </p:txBody>
+      </p:sp>
+      <p:sp>
+        <p:nvSpPr>
+          <p:cNvPr id="18" name="Rectangle 17"/>
+          <p:cNvSpPr/>
+          <p:nvPr/>
+        </p:nvSpPr>
+        <p:spPr>
+          <a:xfrm>
+            <a:off x="4319808" y="3742730"/>
+            <a:ext cx="6323624" cy="18288"/>
+          </a:xfrm>
+          <a:prstGeom prst="rect">
+            <a:avLst/>
+          </a:prstGeom>
+          <a:solidFill>
+            <a:srgbClr val="5234B7"/>
+          </a:solidFill>
+          <a:ln>
+            <a:noFill/>
+          </a:ln>
+          <a:effectLst/>
+        </p:spPr>
+        <p:style>
+          <a:lnRef idx="1">
+            <a:schemeClr val="accent1"/>
+          </a:lnRef>
+          <a:fillRef idx="3">
+            <a:schemeClr val="accent1"/>
+          </a:fillRef>
+          <a:effectRef idx="2">
+            <a:schemeClr val="accent1"/>
+          </a:effectRef>
+          <a:fontRef idx="minor">
+            <a:schemeClr val="lt1"/>
+          </a:fontRef>
+        </p:style>
+        <p:txBody>
+          <a:bodyPr rtlCol="0" anchor="ctr"/>
+          <a:lstStyle/>
+          <a:p>
+            <a:pPr algn="ctr"/>
+          </a:p>
+        </p:txBody>
+      </p:sp>
+      <p:sp>
+        <p:nvSpPr>
+          <p:cNvPr id="19" name="TextBox 18"/>
+          <p:cNvSpPr txBox="1"/>
+          <p:nvPr/>
+        </p:nvSpPr>
+        <p:spPr>
+          <a:xfrm>
+            <a:off x="3968496" y="3817620"/>
+            <a:ext cx="7026249" cy="364845"/>
+          </a:xfrm>
+          <a:prstGeom prst="rect">
+            <a:avLst/>
+          </a:prstGeom>
+          <a:noFill/>
+        </p:spPr>
+        <p:txBody>
+          <a:bodyPr wrap="none" anchor="t">
+            <a:spAutoFit/>
+          </a:bodyPr>
+          <a:lstStyle/>
+          <a:p>
+            <a:pPr algn="ctr"/>
+            <a:r>
+              <a:rPr sz="2000" b="1">
                 <a:solidFill>
                   <a:srgbClr val="5234B7"/>
                 </a:solidFill>
-                <a:latin typeface="DIN Next LT W23"/>
-                <a:ea typeface="DIN Next LT W23"/>
-                <a:cs typeface="DIN Next LT W23"/>
-              </a:rPr>
-              <a:t>) / (x</a:t>
-            </a:r>
-            <a:r>
-              <a:rPr sz="1200" b="1">
+                <a:latin typeface="Helvetica Neue"/>
+                <a:ea typeface="Helvetica Neue"/>
+                <a:cs typeface="Helvetica Neue"/>
+              </a:rPr>
+              <a:t>x</a:t>
+            </a:r>
+            <a:r>
+              <a:rPr sz="1600" b="1" baseline="-25000">
                 <a:solidFill>
                   <a:srgbClr val="5234B7"/>
                 </a:solidFill>
-                <a:latin typeface="DIN Next LT W23"/>
-                <a:ea typeface="DIN Next LT W23"/>
-                <a:cs typeface="DIN Next LT W23"/>
-                <a:baseline val="-25000"/>
+                <a:latin typeface="Helvetica Neue"/>
+                <a:ea typeface="Helvetica Neue"/>
+                <a:cs typeface="Helvetica Neue"/>
               </a:rPr>
               <a:t>max</a:t>
             </a:r>
             <a:r>
-              <a:rPr sz="1800" b="1">
+              <a:rPr sz="2000" b="1">
                 <a:solidFill>
                   <a:srgbClr val="5234B7"/>
                 </a:solidFill>
-                <a:latin typeface="DIN Next LT W23"/>
-                <a:ea typeface="DIN Next LT W23"/>
-                <a:cs typeface="DIN Next LT W23"/>
+                <a:latin typeface="Helvetica Neue"/>
+                <a:ea typeface="Helvetica Neue"/>
+                <a:cs typeface="Helvetica Neue"/>
               </a:rPr>
               <a:t> − x</a:t>
             </a:r>
             <a:r>
-              <a:rPr sz="1200" b="1">
+              <a:rPr sz="1600" b="1" baseline="-25000">
                 <a:solidFill>
                   <a:srgbClr val="5234B7"/>
                 </a:solidFill>
-                <a:latin typeface="DIN Next LT W23"/>
-                <a:ea typeface="DIN Next LT W23"/>
-                <a:cs typeface="DIN Next LT W23"/>
-                <a:baseline val="-25000"/>
+                <a:latin typeface="Helvetica Neue"/>
+                <a:ea typeface="Helvetica Neue"/>
+                <a:cs typeface="Helvetica Neue"/>
               </a:rPr>
               <a:t>min</a:t>
             </a:r>
-            <a:r>
-              <a:rPr sz="1800" b="1">
-                <a:solidFill>
-                  <a:srgbClr val="5234B7"/>
-                </a:solidFill>
-                <a:latin typeface="DIN Next LT W23"/>
-                <a:ea typeface="DIN Next LT W23"/>
-                <a:cs typeface="DIN Next LT W23"/>
-              </a:rPr>
-              <a:t>)</a:t>
-            </a:r>
-          </a:p>
-        </p:txBody>
-      </p:sp>
-      <p:sp>
-        <p:nvSpPr>
-          <p:cNvPr id="17" name="TextBox 16"/>
-          <p:cNvSpPr txBox="1"/>
-          <p:nvPr/>
-        </p:nvSpPr>
-        <p:spPr>
-          <a:xfrm>
-            <a:off x="868680" y="4160520"/>
-            <a:ext cx="10332720" cy="274320"/>
-          </a:xfrm>
-          <a:prstGeom prst="rect">
-            <a:avLst/>
-          </a:prstGeom>
-          <a:noFill/>
-        </p:spPr>
-        <p:txBody>
-          <a:bodyPr wrap="square" anchor="t">
-            <a:spAutoFit/>
-          </a:bodyPr>
-          <a:lstStyle/>
-          <a:p>
-            <a:pPr algn="l"/>
-            <a:r>
-              <a:rPr sz="1300" b="0">
+          </a:p>
+        </p:txBody>
+      </p:sp>
+      <p:sp>
+        <p:nvSpPr>
+          <p:cNvPr id="20" name="TextBox 19"/>
+          <p:cNvSpPr txBox="1"/>
+          <p:nvPr/>
+        </p:nvSpPr>
+        <p:spPr>
+          <a:xfrm>
+            <a:off x="868680" y="4297680"/>
+            <a:ext cx="10332720" cy="256032"/>
+          </a:xfrm>
+          <a:prstGeom prst="rect">
+            <a:avLst/>
+          </a:prstGeom>
+          <a:noFill/>
+        </p:spPr>
+        <p:txBody>
+          <a:bodyPr wrap="square" anchor="t">
+            <a:spAutoFit/>
+          </a:bodyPr>
+          <a:lstStyle/>
+          <a:p>
+            <a:pPr algn="l"/>
+            <a:r>
+              <a:rPr sz="1200" b="0">
                 <a:solidFill>
                   <a:srgbClr val="5A5470"/>
                 </a:solidFill>
-                <a:latin typeface="DIN Next LT W23"/>
-                <a:ea typeface="DIN Next LT W23"/>
-                <a:cs typeface="DIN Next LT W23"/>
+                <a:latin typeface="Helvetica Neue"/>
+                <a:ea typeface="Helvetica Neue"/>
+                <a:cs typeface="Helvetica Neue"/>
               </a:rPr>
               <a:t>x</a:t>
             </a:r>
             <a:r>
-              <a:rPr sz="1100" b="0">
+              <a:rPr sz="1200" b="0" baseline="-25000">
                 <a:solidFill>
                   <a:srgbClr val="5A5470"/>
                 </a:solidFill>
-                <a:latin typeface="DIN Next LT W23"/>
-                <a:ea typeface="DIN Next LT W23"/>
-                <a:cs typeface="DIN Next LT W23"/>
-                <a:baseline val="-25000"/>
+                <a:latin typeface="Helvetica Neue"/>
+                <a:ea typeface="Helvetica Neue"/>
+                <a:cs typeface="Helvetica Neue"/>
               </a:rPr>
               <a:t>min</a:t>
             </a:r>
             <a:r>
-              <a:rPr sz="1300" b="0">
+              <a:rPr sz="1200" b="0">
                 <a:solidFill>
                   <a:srgbClr val="5A5470"/>
                 </a:solidFill>
-                <a:latin typeface="DIN Next LT W23"/>
-                <a:ea typeface="DIN Next LT W23"/>
-                <a:cs typeface="DIN Next LT W23"/>
+                <a:latin typeface="Helvetica Neue"/>
+                <a:ea typeface="Helvetica Neue"/>
+                <a:cs typeface="Helvetica Neue"/>
               </a:rPr>
               <a:t> = 20 · x</a:t>
             </a:r>
             <a:r>
-              <a:rPr sz="1100" b="0">
+              <a:rPr sz="1200" b="0" baseline="-25000">
                 <a:solidFill>
                   <a:srgbClr val="5A5470"/>
                 </a:solidFill>
-                <a:latin typeface="DIN Next LT W23"/>
-                <a:ea typeface="DIN Next LT W23"/>
-                <a:cs typeface="DIN Next LT W23"/>
-                <a:baseline val="-25000"/>
+                <a:latin typeface="Helvetica Neue"/>
+                <a:ea typeface="Helvetica Neue"/>
+                <a:cs typeface="Helvetica Neue"/>
               </a:rPr>
               <a:t>max</a:t>
             </a:r>
             <a:r>
-              <a:rPr sz="1300" b="0">
+              <a:rPr sz="1200" b="0">
                 <a:solidFill>
                   <a:srgbClr val="5A5470"/>
                 </a:solidFill>
-                <a:latin typeface="DIN Next LT W23"/>
-                <a:ea typeface="DIN Next LT W23"/>
-                <a:cs typeface="DIN Next LT W23"/>
+                <a:latin typeface="Helvetica Neue"/>
+                <a:ea typeface="Helvetica Neue"/>
+                <a:cs typeface="Helvetica Neue"/>
               </a:rPr>
               <a:t> = 100</a:t>
             </a:r>
@@ -15697,13 +15997,13 @@
       </p:sp>
       <p:sp>
         <p:nvSpPr>
-          <p:cNvPr id="18" name="Rounded Rectangle 17"/>
+          <p:cNvPr id="21" name="Rounded Rectangle 20"/>
           <p:cNvSpPr/>
           <p:nvPr/>
         </p:nvSpPr>
         <p:spPr>
           <a:xfrm>
-            <a:off x="594360" y="4846320"/>
+            <a:off x="594360" y="4754880"/>
             <a:ext cx="2103120" cy="1051560"/>
           </a:xfrm>
           <a:prstGeom prst="roundRect">
@@ -15743,7 +16043,7 @@
       </p:sp>
       <p:sp>
         <p:nvSpPr>
-          <p:cNvPr id="19" name="TextBox 18"/>
+          <p:cNvPr id="22" name="TextBox 21"/>
           <p:cNvSpPr txBox="1"/>
           <p:nvPr/>
         </p:nvSpPr>
@@ -15780,7 +16080,7 @@
       </p:sp>
       <p:sp>
         <p:nvSpPr>
-          <p:cNvPr id="20" name="TextBox 19"/>
+          <p:cNvPr id="23" name="TextBox 22"/>
           <p:cNvSpPr txBox="1"/>
           <p:nvPr/>
         </p:nvSpPr>
@@ -15817,13 +16117,13 @@
       </p:sp>
       <p:sp>
         <p:nvSpPr>
-          <p:cNvPr id="21" name="Rounded Rectangle 20"/>
+          <p:cNvPr id="24" name="Rounded Rectangle 23"/>
           <p:cNvSpPr/>
           <p:nvPr/>
         </p:nvSpPr>
         <p:spPr>
           <a:xfrm>
-            <a:off x="2788920" y="4846320"/>
+            <a:off x="2788920" y="4754880"/>
             <a:ext cx="2103120" cy="1051560"/>
           </a:xfrm>
           <a:prstGeom prst="roundRect">
@@ -15863,7 +16163,7 @@
       </p:sp>
       <p:sp>
         <p:nvSpPr>
-          <p:cNvPr id="22" name="TextBox 21"/>
+          <p:cNvPr id="25" name="TextBox 24"/>
           <p:cNvSpPr txBox="1"/>
           <p:nvPr/>
         </p:nvSpPr>
@@ -15900,7 +16200,7 @@
       </p:sp>
       <p:sp>
         <p:nvSpPr>
-          <p:cNvPr id="23" name="TextBox 22"/>
+          <p:cNvPr id="26" name="TextBox 25"/>
           <p:cNvSpPr txBox="1"/>
           <p:nvPr/>
         </p:nvSpPr>
@@ -15937,13 +16237,13 @@
       </p:sp>
       <p:sp>
         <p:nvSpPr>
-          <p:cNvPr id="24" name="Rounded Rectangle 23"/>
+          <p:cNvPr id="27" name="Rounded Rectangle 26"/>
           <p:cNvSpPr/>
           <p:nvPr/>
         </p:nvSpPr>
         <p:spPr>
           <a:xfrm>
-            <a:off x="4983480" y="4846320"/>
+            <a:off x="4983480" y="4754880"/>
             <a:ext cx="2103120" cy="1051560"/>
           </a:xfrm>
           <a:prstGeom prst="roundRect">
@@ -15983,7 +16283,7 @@
       </p:sp>
       <p:sp>
         <p:nvSpPr>
-          <p:cNvPr id="25" name="TextBox 24"/>
+          <p:cNvPr id="28" name="TextBox 27"/>
           <p:cNvSpPr txBox="1"/>
           <p:nvPr/>
         </p:nvSpPr>
@@ -16020,7 +16320,7 @@
       </p:sp>
       <p:sp>
         <p:nvSpPr>
-          <p:cNvPr id="26" name="TextBox 25"/>
+          <p:cNvPr id="29" name="TextBox 28"/>
           <p:cNvSpPr txBox="1"/>
           <p:nvPr/>
         </p:nvSpPr>
@@ -16057,13 +16357,13 @@
       </p:sp>
       <p:sp>
         <p:nvSpPr>
-          <p:cNvPr id="27" name="Rounded Rectangle 26"/>
+          <p:cNvPr id="30" name="Rounded Rectangle 29"/>
           <p:cNvSpPr/>
           <p:nvPr/>
         </p:nvSpPr>
         <p:spPr>
           <a:xfrm>
-            <a:off x="7178040" y="4846320"/>
+            <a:off x="7178040" y="4754880"/>
             <a:ext cx="2103120" cy="1051560"/>
           </a:xfrm>
           <a:prstGeom prst="roundRect">
@@ -16103,7 +16403,7 @@
       </p:sp>
       <p:sp>
         <p:nvSpPr>
-          <p:cNvPr id="28" name="TextBox 27"/>
+          <p:cNvPr id="31" name="TextBox 30"/>
           <p:cNvSpPr txBox="1"/>
           <p:nvPr/>
         </p:nvSpPr>
@@ -16140,7 +16440,7 @@
       </p:sp>
       <p:sp>
         <p:nvSpPr>
-          <p:cNvPr id="29" name="TextBox 28"/>
+          <p:cNvPr id="32" name="TextBox 31"/>
           <p:cNvSpPr txBox="1"/>
           <p:nvPr/>
         </p:nvSpPr>
@@ -16177,13 +16477,13 @@
       </p:sp>
       <p:sp>
         <p:nvSpPr>
-          <p:cNvPr id="30" name="Rounded Rectangle 29"/>
+          <p:cNvPr id="33" name="Rounded Rectangle 32"/>
           <p:cNvSpPr/>
           <p:nvPr/>
         </p:nvSpPr>
         <p:spPr>
           <a:xfrm>
-            <a:off x="9372600" y="4846320"/>
+            <a:off x="9372600" y="4754880"/>
             <a:ext cx="2103120" cy="1051560"/>
           </a:xfrm>
           <a:prstGeom prst="roundRect">
@@ -16223,7 +16523,7 @@
       </p:sp>
       <p:sp>
         <p:nvSpPr>
-          <p:cNvPr id="31" name="TextBox 30"/>
+          <p:cNvPr id="34" name="TextBox 33"/>
           <p:cNvSpPr txBox="1"/>
           <p:nvPr/>
         </p:nvSpPr>
@@ -16260,7 +16560,7 @@
       </p:sp>
       <p:sp>
         <p:nvSpPr>
-          <p:cNvPr id="32" name="TextBox 31"/>
+          <p:cNvPr id="35" name="TextBox 34"/>
           <p:cNvSpPr txBox="1"/>
           <p:nvPr/>
         </p:nvSpPr>
@@ -16297,7 +16597,7 @@
       </p:sp>
       <p:sp>
         <p:nvSpPr>
-          <p:cNvPr id="33" name="Rectangle 32"/>
+          <p:cNvPr id="36" name="Rectangle 35"/>
           <p:cNvSpPr/>
           <p:nvPr/>
         </p:nvSpPr>
@@ -16341,7 +16641,7 @@
       </p:sp>
       <p:sp>
         <p:nvSpPr>
-          <p:cNvPr id="34" name="TextBox 33"/>
+          <p:cNvPr id="37" name="TextBox 36"/>
           <p:cNvSpPr txBox="1"/>
           <p:nvPr/>
         </p:nvSpPr>
@@ -16378,7 +16678,7 @@
       </p:sp>
       <p:sp>
         <p:nvSpPr>
-          <p:cNvPr id="35" name="TextBox 34"/>
+          <p:cNvPr id="38" name="TextBox 37"/>
           <p:cNvSpPr txBox="1"/>
           <p:nvPr/>
         </p:nvSpPr>
@@ -16670,8 +16970,8 @@
         </p:nvSpPr>
         <p:spPr>
           <a:xfrm>
-            <a:off x="548640" y="2011680"/>
-            <a:ext cx="10972800" cy="1051560"/>
+            <a:off x="548640" y="1965960"/>
+            <a:ext cx="10972800" cy="1417320"/>
           </a:xfrm>
           <a:prstGeom prst="roundRect">
             <a:avLst>
@@ -16716,204 +17016,294 @@
         </p:nvSpPr>
         <p:spPr>
           <a:xfrm>
-            <a:off x="868680" y="2148840"/>
-            <a:ext cx="10332720" cy="320040"/>
-          </a:xfrm>
-          <a:prstGeom prst="rect">
-            <a:avLst/>
-          </a:prstGeom>
-          <a:noFill/>
-        </p:spPr>
-        <p:txBody>
-          <a:bodyPr wrap="square" anchor="t">
-            <a:spAutoFit/>
-          </a:bodyPr>
-          <a:lstStyle/>
-          <a:p>
-            <a:pPr algn="l"/>
-            <a:r>
-              <a:rPr sz="1800" b="1">
+            <a:off x="868680" y="2057400"/>
+            <a:ext cx="2893161" cy="960120"/>
+          </a:xfrm>
+          <a:prstGeom prst="rect">
+            <a:avLst/>
+          </a:prstGeom>
+          <a:noFill/>
+        </p:spPr>
+        <p:txBody>
+          <a:bodyPr wrap="none" anchor="ctr">
+            <a:spAutoFit/>
+          </a:bodyPr>
+          <a:lstStyle/>
+          <a:p>
+            <a:pPr algn="r"/>
+            <a:r>
+              <a:rPr sz="2000" b="1">
                 <a:solidFill>
                   <a:srgbClr val="5234B7"/>
                 </a:solidFill>
-                <a:latin typeface="DIN Next LT W23"/>
-                <a:ea typeface="DIN Next LT W23"/>
-                <a:cs typeface="DIN Next LT W23"/>
+                <a:latin typeface="Helvetica Neue"/>
+                <a:ea typeface="Helvetica Neue"/>
+                <a:cs typeface="Helvetica Neue"/>
               </a:rPr>
               <a:t>x</a:t>
             </a:r>
             <a:r>
-              <a:rPr sz="1200" b="1">
+              <a:rPr sz="1600" b="1" baseline="-25000">
                 <a:solidFill>
                   <a:srgbClr val="5234B7"/>
                 </a:solidFill>
-                <a:latin typeface="DIN Next LT W23"/>
-                <a:ea typeface="DIN Next LT W23"/>
-                <a:cs typeface="DIN Next LT W23"/>
-                <a:baseline val="-25000"/>
+                <a:latin typeface="Helvetica Neue"/>
+                <a:ea typeface="Helvetica Neue"/>
+                <a:cs typeface="Helvetica Neue"/>
               </a:rPr>
               <a:t>norm</a:t>
             </a:r>
             <a:r>
-              <a:rPr sz="1800" b="1">
+              <a:rPr sz="2000" b="1">
                 <a:solidFill>
                   <a:srgbClr val="5234B7"/>
                 </a:solidFill>
-                <a:latin typeface="DIN Next LT W23"/>
-                <a:ea typeface="DIN Next LT W23"/>
-                <a:cs typeface="DIN Next LT W23"/>
-              </a:rPr>
-              <a:t> = (x − x</a:t>
-            </a:r>
-            <a:r>
-              <a:rPr sz="1200" b="1">
+                <a:latin typeface="Helvetica Neue"/>
+                <a:ea typeface="Helvetica Neue"/>
+                <a:cs typeface="Helvetica Neue"/>
+              </a:rPr>
+              <a:t> =</a:t>
+            </a:r>
+          </a:p>
+        </p:txBody>
+      </p:sp>
+      <p:sp>
+        <p:nvSpPr>
+          <p:cNvPr id="10" name="TextBox 9"/>
+          <p:cNvSpPr txBox="1"/>
+          <p:nvPr/>
+        </p:nvSpPr>
+        <p:spPr>
+          <a:xfrm>
+            <a:off x="3968496" y="2057400"/>
+            <a:ext cx="7026249" cy="364845"/>
+          </a:xfrm>
+          <a:prstGeom prst="rect">
+            <a:avLst/>
+          </a:prstGeom>
+          <a:noFill/>
+        </p:spPr>
+        <p:txBody>
+          <a:bodyPr wrap="none" anchor="b">
+            <a:spAutoFit/>
+          </a:bodyPr>
+          <a:lstStyle/>
+          <a:p>
+            <a:pPr algn="ctr"/>
+            <a:r>
+              <a:rPr sz="2000" b="1">
                 <a:solidFill>
                   <a:srgbClr val="5234B7"/>
                 </a:solidFill>
-                <a:latin typeface="DIN Next LT W23"/>
-                <a:ea typeface="DIN Next LT W23"/>
-                <a:cs typeface="DIN Next LT W23"/>
-                <a:baseline val="-25000"/>
+                <a:latin typeface="Helvetica Neue"/>
+                <a:ea typeface="Helvetica Neue"/>
+                <a:cs typeface="Helvetica Neue"/>
+              </a:rPr>
+              <a:t>x − x</a:t>
+            </a:r>
+            <a:r>
+              <a:rPr sz="1600" b="1" baseline="-25000">
+                <a:solidFill>
+                  <a:srgbClr val="5234B7"/>
+                </a:solidFill>
+                <a:latin typeface="Helvetica Neue"/>
+                <a:ea typeface="Helvetica Neue"/>
+                <a:cs typeface="Helvetica Neue"/>
               </a:rPr>
               <a:t>min</a:t>
             </a:r>
-            <a:r>
-              <a:rPr sz="1800" b="1">
+          </a:p>
+        </p:txBody>
+      </p:sp>
+      <p:sp>
+        <p:nvSpPr>
+          <p:cNvPr id="11" name="Rectangle 10"/>
+          <p:cNvSpPr/>
+          <p:nvPr/>
+        </p:nvSpPr>
+        <p:spPr>
+          <a:xfrm>
+            <a:off x="4319808" y="2462570"/>
+            <a:ext cx="6323624" cy="18288"/>
+          </a:xfrm>
+          <a:prstGeom prst="rect">
+            <a:avLst/>
+          </a:prstGeom>
+          <a:solidFill>
+            <a:srgbClr val="5234B7"/>
+          </a:solidFill>
+          <a:ln>
+            <a:noFill/>
+          </a:ln>
+          <a:effectLst/>
+        </p:spPr>
+        <p:style>
+          <a:lnRef idx="1">
+            <a:schemeClr val="accent1"/>
+          </a:lnRef>
+          <a:fillRef idx="3">
+            <a:schemeClr val="accent1"/>
+          </a:fillRef>
+          <a:effectRef idx="2">
+            <a:schemeClr val="accent1"/>
+          </a:effectRef>
+          <a:fontRef idx="minor">
+            <a:schemeClr val="lt1"/>
+          </a:fontRef>
+        </p:style>
+        <p:txBody>
+          <a:bodyPr rtlCol="0" anchor="ctr"/>
+          <a:lstStyle/>
+          <a:p>
+            <a:pPr algn="ctr"/>
+          </a:p>
+        </p:txBody>
+      </p:sp>
+      <p:sp>
+        <p:nvSpPr>
+          <p:cNvPr id="12" name="TextBox 11"/>
+          <p:cNvSpPr txBox="1"/>
+          <p:nvPr/>
+        </p:nvSpPr>
+        <p:spPr>
+          <a:xfrm>
+            <a:off x="3968496" y="2537460"/>
+            <a:ext cx="7026249" cy="364845"/>
+          </a:xfrm>
+          <a:prstGeom prst="rect">
+            <a:avLst/>
+          </a:prstGeom>
+          <a:noFill/>
+        </p:spPr>
+        <p:txBody>
+          <a:bodyPr wrap="none" anchor="t">
+            <a:spAutoFit/>
+          </a:bodyPr>
+          <a:lstStyle/>
+          <a:p>
+            <a:pPr algn="ctr"/>
+            <a:r>
+              <a:rPr sz="2000" b="1">
                 <a:solidFill>
                   <a:srgbClr val="5234B7"/>
                 </a:solidFill>
-                <a:latin typeface="DIN Next LT W23"/>
-                <a:ea typeface="DIN Next LT W23"/>
-                <a:cs typeface="DIN Next LT W23"/>
-              </a:rPr>
-              <a:t>) / (x</a:t>
-            </a:r>
-            <a:r>
-              <a:rPr sz="1200" b="1">
+                <a:latin typeface="Helvetica Neue"/>
+                <a:ea typeface="Helvetica Neue"/>
+                <a:cs typeface="Helvetica Neue"/>
+              </a:rPr>
+              <a:t>x</a:t>
+            </a:r>
+            <a:r>
+              <a:rPr sz="1600" b="1" baseline="-25000">
                 <a:solidFill>
                   <a:srgbClr val="5234B7"/>
                 </a:solidFill>
-                <a:latin typeface="DIN Next LT W23"/>
-                <a:ea typeface="DIN Next LT W23"/>
-                <a:cs typeface="DIN Next LT W23"/>
-                <a:baseline val="-25000"/>
+                <a:latin typeface="Helvetica Neue"/>
+                <a:ea typeface="Helvetica Neue"/>
+                <a:cs typeface="Helvetica Neue"/>
               </a:rPr>
               <a:t>max</a:t>
             </a:r>
             <a:r>
-              <a:rPr sz="1800" b="1">
+              <a:rPr sz="2000" b="1">
                 <a:solidFill>
                   <a:srgbClr val="5234B7"/>
                 </a:solidFill>
-                <a:latin typeface="DIN Next LT W23"/>
-                <a:ea typeface="DIN Next LT W23"/>
-                <a:cs typeface="DIN Next LT W23"/>
+                <a:latin typeface="Helvetica Neue"/>
+                <a:ea typeface="Helvetica Neue"/>
+                <a:cs typeface="Helvetica Neue"/>
               </a:rPr>
               <a:t> − x</a:t>
             </a:r>
             <a:r>
-              <a:rPr sz="1200" b="1">
+              <a:rPr sz="1600" b="1" baseline="-25000">
                 <a:solidFill>
                   <a:srgbClr val="5234B7"/>
                 </a:solidFill>
-                <a:latin typeface="DIN Next LT W23"/>
-                <a:ea typeface="DIN Next LT W23"/>
-                <a:cs typeface="DIN Next LT W23"/>
-                <a:baseline val="-25000"/>
+                <a:latin typeface="Helvetica Neue"/>
+                <a:ea typeface="Helvetica Neue"/>
+                <a:cs typeface="Helvetica Neue"/>
               </a:rPr>
               <a:t>min</a:t>
             </a:r>
-            <a:r>
-              <a:rPr sz="1800" b="1">
-                <a:solidFill>
-                  <a:srgbClr val="5234B7"/>
-                </a:solidFill>
-                <a:latin typeface="DIN Next LT W23"/>
-                <a:ea typeface="DIN Next LT W23"/>
-                <a:cs typeface="DIN Next LT W23"/>
-              </a:rPr>
-              <a:t>)</a:t>
-            </a:r>
-          </a:p>
-        </p:txBody>
-      </p:sp>
-      <p:sp>
-        <p:nvSpPr>
-          <p:cNvPr id="10" name="TextBox 9"/>
-          <p:cNvSpPr txBox="1"/>
-          <p:nvPr/>
-        </p:nvSpPr>
-        <p:spPr>
-          <a:xfrm>
-            <a:off x="868680" y="2560320"/>
-            <a:ext cx="10332720" cy="274320"/>
-          </a:xfrm>
-          <a:prstGeom prst="rect">
-            <a:avLst/>
-          </a:prstGeom>
-          <a:noFill/>
-        </p:spPr>
-        <p:txBody>
-          <a:bodyPr wrap="square" anchor="t">
-            <a:spAutoFit/>
-          </a:bodyPr>
-          <a:lstStyle/>
-          <a:p>
-            <a:pPr algn="l"/>
-            <a:r>
-              <a:rPr sz="1300" b="0">
+          </a:p>
+        </p:txBody>
+      </p:sp>
+      <p:sp>
+        <p:nvSpPr>
+          <p:cNvPr id="13" name="TextBox 12"/>
+          <p:cNvSpPr txBox="1"/>
+          <p:nvPr/>
+        </p:nvSpPr>
+        <p:spPr>
+          <a:xfrm>
+            <a:off x="868680" y="3017520"/>
+            <a:ext cx="10332720" cy="256032"/>
+          </a:xfrm>
+          <a:prstGeom prst="rect">
+            <a:avLst/>
+          </a:prstGeom>
+          <a:noFill/>
+        </p:spPr>
+        <p:txBody>
+          <a:bodyPr wrap="square" anchor="t">
+            <a:spAutoFit/>
+          </a:bodyPr>
+          <a:lstStyle/>
+          <a:p>
+            <a:pPr algn="l"/>
+            <a:r>
+              <a:rPr sz="1200" b="0">
                 <a:solidFill>
                   <a:srgbClr val="5A5470"/>
                 </a:solidFill>
-                <a:latin typeface="DIN Next LT W23"/>
-                <a:ea typeface="DIN Next LT W23"/>
-                <a:cs typeface="DIN Next LT W23"/>
+                <a:latin typeface="Helvetica Neue"/>
+                <a:ea typeface="Helvetica Neue"/>
+                <a:cs typeface="Helvetica Neue"/>
               </a:rPr>
               <a:t>x</a:t>
             </a:r>
             <a:r>
-              <a:rPr sz="1100" b="0">
+              <a:rPr sz="1200" b="0" baseline="-25000">
                 <a:solidFill>
                   <a:srgbClr val="5A5470"/>
                 </a:solidFill>
-                <a:latin typeface="DIN Next LT W23"/>
-                <a:ea typeface="DIN Next LT W23"/>
-                <a:cs typeface="DIN Next LT W23"/>
-                <a:baseline val="-25000"/>
+                <a:latin typeface="Helvetica Neue"/>
+                <a:ea typeface="Helvetica Neue"/>
+                <a:cs typeface="Helvetica Neue"/>
               </a:rPr>
               <a:t>min</a:t>
             </a:r>
             <a:r>
-              <a:rPr sz="1300" b="0">
+              <a:rPr sz="1200" b="0">
                 <a:solidFill>
                   <a:srgbClr val="5A5470"/>
                 </a:solidFill>
-                <a:latin typeface="DIN Next LT W23"/>
-                <a:ea typeface="DIN Next LT W23"/>
-                <a:cs typeface="DIN Next LT W23"/>
+                <a:latin typeface="Helvetica Neue"/>
+                <a:ea typeface="Helvetica Neue"/>
+                <a:cs typeface="Helvetica Neue"/>
               </a:rPr>
               <a:t> = 20 · x</a:t>
             </a:r>
             <a:r>
-              <a:rPr sz="1100" b="0">
+              <a:rPr sz="1200" b="0" baseline="-25000">
                 <a:solidFill>
                   <a:srgbClr val="5A5470"/>
                 </a:solidFill>
-                <a:latin typeface="DIN Next LT W23"/>
-                <a:ea typeface="DIN Next LT W23"/>
-                <a:cs typeface="DIN Next LT W23"/>
-                <a:baseline val="-25000"/>
+                <a:latin typeface="Helvetica Neue"/>
+                <a:ea typeface="Helvetica Neue"/>
+                <a:cs typeface="Helvetica Neue"/>
               </a:rPr>
               <a:t>max</a:t>
             </a:r>
             <a:r>
-              <a:rPr sz="1300" b="0">
+              <a:rPr sz="1200" b="0">
                 <a:solidFill>
                   <a:srgbClr val="5A5470"/>
                 </a:solidFill>
-                <a:latin typeface="DIN Next LT W23"/>
-                <a:ea typeface="DIN Next LT W23"/>
-                <a:cs typeface="DIN Next LT W23"/>
+                <a:latin typeface="Helvetica Neue"/>
+                <a:ea typeface="Helvetica Neue"/>
+                <a:cs typeface="Helvetica Neue"/>
               </a:rPr>
               <a:t> = 100</a:t>
             </a:r>
@@ -16922,15 +17312,15 @@
       </p:sp>
       <p:graphicFrame>
         <p:nvGraphicFramePr>
-          <p:cNvPr id="11" name="Table 10"/>
+          <p:cNvPr id="14" name="Table 13"/>
           <p:cNvGraphicFramePr>
             <a:graphicFrameLocks noGrp="1"/>
           </p:cNvGraphicFramePr>
           <p:nvPr/>
         </p:nvGraphicFramePr>
         <p:xfrm>
-          <a:off x="548640" y="3246120"/>
-          <a:ext cx="10972800" cy="2240280"/>
+          <a:off x="548640" y="3566160"/>
+          <a:ext cx="10972800" cy="2011680"/>
         </p:xfrm>
         <a:graphic>
           <a:graphicData uri="http://schemas.openxmlformats.org/drawingml/2006/table">
@@ -16942,7 +17332,7 @@
                 <a:gridCol w="5486400"/>
                 <a:gridCol w="5486400"/>
               </a:tblGrid>
-              <a:tr h="373380">
+              <a:tr h="335280">
                 <a:tc>
                   <a:txBody>
                     <a:bodyPr/>
@@ -16990,7 +17380,7 @@
                   </a:tcPr>
                 </a:tc>
               </a:tr>
-              <a:tr h="373380">
+              <a:tr h="335280">
                 <a:tc>
                   <a:txBody>
                     <a:bodyPr/>
@@ -17038,7 +17428,7 @@
                   </a:tcPr>
                 </a:tc>
               </a:tr>
-              <a:tr h="373380">
+              <a:tr h="335280">
                 <a:tc>
                   <a:txBody>
                     <a:bodyPr/>
@@ -17086,7 +17476,7 @@
                   </a:tcPr>
                 </a:tc>
               </a:tr>
-              <a:tr h="373380">
+              <a:tr h="335280">
                 <a:tc>
                   <a:txBody>
                     <a:bodyPr/>
@@ -17134,7 +17524,7 @@
                   </a:tcPr>
                 </a:tc>
               </a:tr>
-              <a:tr h="373380">
+              <a:tr h="335280">
                 <a:tc>
                   <a:txBody>
                     <a:bodyPr/>
@@ -17182,7 +17572,7 @@
                   </a:tcPr>
                 </a:tc>
               </a:tr>
-              <a:tr h="373380">
+              <a:tr h="335280">
                 <a:tc>
                   <a:txBody>
                     <a:bodyPr/>
@@ -17236,7 +17626,7 @@
       </p:graphicFrame>
       <p:sp>
         <p:nvSpPr>
-          <p:cNvPr id="12" name="TextBox 11"/>
+          <p:cNvPr id="15" name="TextBox 14"/>
           <p:cNvSpPr txBox="1"/>
           <p:nvPr/>
         </p:nvSpPr>
@@ -17273,7 +17663,7 @@
       </p:sp>
       <p:sp>
         <p:nvSpPr>
-          <p:cNvPr id="13" name="Rectangle 12"/>
+          <p:cNvPr id="16" name="Rectangle 15"/>
           <p:cNvSpPr/>
           <p:nvPr/>
         </p:nvSpPr>
@@ -17317,7 +17707,7 @@
       </p:sp>
       <p:sp>
         <p:nvSpPr>
-          <p:cNvPr id="14" name="TextBox 13"/>
+          <p:cNvPr id="17" name="TextBox 16"/>
           <p:cNvSpPr txBox="1"/>
           <p:nvPr/>
         </p:nvSpPr>
@@ -17354,7 +17744,7 @@
       </p:sp>
       <p:sp>
         <p:nvSpPr>
-          <p:cNvPr id="15" name="TextBox 14"/>
+          <p:cNvPr id="18" name="TextBox 17"/>
           <p:cNvSpPr txBox="1"/>
           <p:nvPr/>
         </p:nvSpPr>
@@ -17923,8 +18313,8 @@
         </p:nvSpPr>
         <p:spPr>
           <a:xfrm>
-            <a:off x="548640" y="3611880"/>
-            <a:ext cx="10972800" cy="1051560"/>
+            <a:off x="548640" y="3246120"/>
+            <a:ext cx="10972800" cy="1417320"/>
           </a:xfrm>
           <a:prstGeom prst="roundRect">
             <a:avLst>
@@ -17969,31 +18359,31 @@
         </p:nvSpPr>
         <p:spPr>
           <a:xfrm>
-            <a:off x="868680" y="3749039"/>
-            <a:ext cx="10332720" cy="320040"/>
-          </a:xfrm>
-          <a:prstGeom prst="rect">
-            <a:avLst/>
-          </a:prstGeom>
-          <a:noFill/>
-        </p:spPr>
-        <p:txBody>
-          <a:bodyPr wrap="square" anchor="t">
-            <a:spAutoFit/>
-          </a:bodyPr>
-          <a:lstStyle/>
-          <a:p>
-            <a:pPr algn="l"/>
-            <a:r>
-              <a:rPr sz="1800" b="1">
+            <a:off x="868680" y="3337560"/>
+            <a:ext cx="2893161" cy="960120"/>
+          </a:xfrm>
+          <a:prstGeom prst="rect">
+            <a:avLst/>
+          </a:prstGeom>
+          <a:noFill/>
+        </p:spPr>
+        <p:txBody>
+          <a:bodyPr wrap="none" anchor="ctr">
+            <a:spAutoFit/>
+          </a:bodyPr>
+          <a:lstStyle/>
+          <a:p>
+            <a:pPr algn="r"/>
+            <a:r>
+              <a:rPr sz="2000" b="1">
                 <a:solidFill>
                   <a:srgbClr val="5234B7"/>
                 </a:solidFill>
-                <a:latin typeface="DIN Next LT W23"/>
-                <a:ea typeface="DIN Next LT W23"/>
-                <a:cs typeface="DIN Next LT W23"/>
-              </a:rPr>
-              <a:t>z = (x − μ) / σ</a:t>
+                <a:latin typeface="Helvetica Neue"/>
+                <a:ea typeface="Helvetica Neue"/>
+                <a:cs typeface="Helvetica Neue"/>
+              </a:rPr>
+              <a:t>z =</a:t>
             </a:r>
           </a:p>
         </p:txBody>
@@ -18006,29 +18396,147 @@
         </p:nvSpPr>
         <p:spPr>
           <a:xfrm>
-            <a:off x="868680" y="4160520"/>
-            <a:ext cx="10332720" cy="274320"/>
-          </a:xfrm>
-          <a:prstGeom prst="rect">
-            <a:avLst/>
-          </a:prstGeom>
-          <a:noFill/>
-        </p:spPr>
-        <p:txBody>
-          <a:bodyPr wrap="square" anchor="t">
-            <a:spAutoFit/>
-          </a:bodyPr>
-          <a:lstStyle/>
-          <a:p>
-            <a:pPr algn="l"/>
-            <a:r>
-              <a:rPr sz="1300" b="0">
+            <a:off x="3968496" y="3337560"/>
+            <a:ext cx="7026249" cy="364845"/>
+          </a:xfrm>
+          <a:prstGeom prst="rect">
+            <a:avLst/>
+          </a:prstGeom>
+          <a:noFill/>
+        </p:spPr>
+        <p:txBody>
+          <a:bodyPr wrap="none" anchor="b">
+            <a:spAutoFit/>
+          </a:bodyPr>
+          <a:lstStyle/>
+          <a:p>
+            <a:pPr algn="ctr"/>
+            <a:r>
+              <a:rPr sz="2000" b="1">
+                <a:solidFill>
+                  <a:srgbClr val="5234B7"/>
+                </a:solidFill>
+                <a:latin typeface="Helvetica Neue"/>
+                <a:ea typeface="Helvetica Neue"/>
+                <a:cs typeface="Helvetica Neue"/>
+              </a:rPr>
+              <a:t>x − μ</a:t>
+            </a:r>
+          </a:p>
+        </p:txBody>
+      </p:sp>
+      <p:sp>
+        <p:nvSpPr>
+          <p:cNvPr id="18" name="Rectangle 17"/>
+          <p:cNvSpPr/>
+          <p:nvPr/>
+        </p:nvSpPr>
+        <p:spPr>
+          <a:xfrm>
+            <a:off x="4319808" y="3742730"/>
+            <a:ext cx="6323624" cy="18288"/>
+          </a:xfrm>
+          <a:prstGeom prst="rect">
+            <a:avLst/>
+          </a:prstGeom>
+          <a:solidFill>
+            <a:srgbClr val="5234B7"/>
+          </a:solidFill>
+          <a:ln>
+            <a:noFill/>
+          </a:ln>
+          <a:effectLst/>
+        </p:spPr>
+        <p:style>
+          <a:lnRef idx="1">
+            <a:schemeClr val="accent1"/>
+          </a:lnRef>
+          <a:fillRef idx="3">
+            <a:schemeClr val="accent1"/>
+          </a:fillRef>
+          <a:effectRef idx="2">
+            <a:schemeClr val="accent1"/>
+          </a:effectRef>
+          <a:fontRef idx="minor">
+            <a:schemeClr val="lt1"/>
+          </a:fontRef>
+        </p:style>
+        <p:txBody>
+          <a:bodyPr rtlCol="0" anchor="ctr"/>
+          <a:lstStyle/>
+          <a:p>
+            <a:pPr algn="ctr"/>
+          </a:p>
+        </p:txBody>
+      </p:sp>
+      <p:sp>
+        <p:nvSpPr>
+          <p:cNvPr id="19" name="TextBox 18"/>
+          <p:cNvSpPr txBox="1"/>
+          <p:nvPr/>
+        </p:nvSpPr>
+        <p:spPr>
+          <a:xfrm>
+            <a:off x="3968496" y="3817620"/>
+            <a:ext cx="7026249" cy="364845"/>
+          </a:xfrm>
+          <a:prstGeom prst="rect">
+            <a:avLst/>
+          </a:prstGeom>
+          <a:noFill/>
+        </p:spPr>
+        <p:txBody>
+          <a:bodyPr wrap="none" anchor="t">
+            <a:spAutoFit/>
+          </a:bodyPr>
+          <a:lstStyle/>
+          <a:p>
+            <a:pPr algn="ctr"/>
+            <a:r>
+              <a:rPr sz="2000" b="1">
+                <a:solidFill>
+                  <a:srgbClr val="5234B7"/>
+                </a:solidFill>
+                <a:latin typeface="Helvetica Neue"/>
+                <a:ea typeface="Helvetica Neue"/>
+                <a:cs typeface="Helvetica Neue"/>
+              </a:rPr>
+              <a:t>σ</a:t>
+            </a:r>
+          </a:p>
+        </p:txBody>
+      </p:sp>
+      <p:sp>
+        <p:nvSpPr>
+          <p:cNvPr id="20" name="TextBox 19"/>
+          <p:cNvSpPr txBox="1"/>
+          <p:nvPr/>
+        </p:nvSpPr>
+        <p:spPr>
+          <a:xfrm>
+            <a:off x="868680" y="4297680"/>
+            <a:ext cx="10332720" cy="256032"/>
+          </a:xfrm>
+          <a:prstGeom prst="rect">
+            <a:avLst/>
+          </a:prstGeom>
+          <a:noFill/>
+        </p:spPr>
+        <p:txBody>
+          <a:bodyPr wrap="square" anchor="t">
+            <a:spAutoFit/>
+          </a:bodyPr>
+          <a:lstStyle/>
+          <a:p>
+            <a:pPr algn="l"/>
+            <a:r>
+              <a:rPr sz="1200" b="0">
                 <a:solidFill>
                   <a:srgbClr val="5A5470"/>
                 </a:solidFill>
-                <a:latin typeface="DIN Next LT W23"/>
-                <a:ea typeface="DIN Next LT W23"/>
-                <a:cs typeface="DIN Next LT W23"/>
+                <a:latin typeface="Helvetica Neue"/>
+                <a:ea typeface="Helvetica Neue"/>
+                <a:cs typeface="Helvetica Neue"/>
               </a:rPr>
               <a:t>Mean: μ = 60 · Standard deviation: σ = 28.28</a:t>
             </a:r>
@@ -18037,13 +18545,13 @@
       </p:sp>
       <p:sp>
         <p:nvSpPr>
-          <p:cNvPr id="18" name="Rounded Rectangle 17"/>
+          <p:cNvPr id="21" name="Rounded Rectangle 20"/>
           <p:cNvSpPr/>
           <p:nvPr/>
         </p:nvSpPr>
         <p:spPr>
           <a:xfrm>
-            <a:off x="594360" y="4846320"/>
+            <a:off x="594360" y="4754880"/>
             <a:ext cx="2103120" cy="1051560"/>
           </a:xfrm>
           <a:prstGeom prst="roundRect">
@@ -18083,7 +18591,7 @@
       </p:sp>
       <p:sp>
         <p:nvSpPr>
-          <p:cNvPr id="19" name="TextBox 18"/>
+          <p:cNvPr id="22" name="TextBox 21"/>
           <p:cNvSpPr txBox="1"/>
           <p:nvPr/>
         </p:nvSpPr>
@@ -18120,7 +18628,7 @@
       </p:sp>
       <p:sp>
         <p:nvSpPr>
-          <p:cNvPr id="20" name="TextBox 19"/>
+          <p:cNvPr id="23" name="TextBox 22"/>
           <p:cNvSpPr txBox="1"/>
           <p:nvPr/>
         </p:nvSpPr>
@@ -18157,13 +18665,13 @@
       </p:sp>
       <p:sp>
         <p:nvSpPr>
-          <p:cNvPr id="21" name="Rounded Rectangle 20"/>
+          <p:cNvPr id="24" name="Rounded Rectangle 23"/>
           <p:cNvSpPr/>
           <p:nvPr/>
         </p:nvSpPr>
         <p:spPr>
           <a:xfrm>
-            <a:off x="2788920" y="4846320"/>
+            <a:off x="2788920" y="4754880"/>
             <a:ext cx="2103120" cy="1051560"/>
           </a:xfrm>
           <a:prstGeom prst="roundRect">
@@ -18203,7 +18711,7 @@
       </p:sp>
       <p:sp>
         <p:nvSpPr>
-          <p:cNvPr id="22" name="TextBox 21"/>
+          <p:cNvPr id="25" name="TextBox 24"/>
           <p:cNvSpPr txBox="1"/>
           <p:nvPr/>
         </p:nvSpPr>
@@ -18240,7 +18748,7 @@
       </p:sp>
       <p:sp>
         <p:nvSpPr>
-          <p:cNvPr id="23" name="TextBox 22"/>
+          <p:cNvPr id="26" name="TextBox 25"/>
           <p:cNvSpPr txBox="1"/>
           <p:nvPr/>
         </p:nvSpPr>
@@ -18277,13 +18785,13 @@
       </p:sp>
       <p:sp>
         <p:nvSpPr>
-          <p:cNvPr id="24" name="Rounded Rectangle 23"/>
+          <p:cNvPr id="27" name="Rounded Rectangle 26"/>
           <p:cNvSpPr/>
           <p:nvPr/>
         </p:nvSpPr>
         <p:spPr>
           <a:xfrm>
-            <a:off x="4983480" y="4846320"/>
+            <a:off x="4983480" y="4754880"/>
             <a:ext cx="2103120" cy="1051560"/>
           </a:xfrm>
           <a:prstGeom prst="roundRect">
@@ -18323,7 +18831,7 @@
       </p:sp>
       <p:sp>
         <p:nvSpPr>
-          <p:cNvPr id="25" name="TextBox 24"/>
+          <p:cNvPr id="28" name="TextBox 27"/>
           <p:cNvSpPr txBox="1"/>
           <p:nvPr/>
         </p:nvSpPr>
@@ -18360,7 +18868,7 @@
       </p:sp>
       <p:sp>
         <p:nvSpPr>
-          <p:cNvPr id="26" name="TextBox 25"/>
+          <p:cNvPr id="29" name="TextBox 28"/>
           <p:cNvSpPr txBox="1"/>
           <p:nvPr/>
         </p:nvSpPr>
@@ -18397,13 +18905,13 @@
       </p:sp>
       <p:sp>
         <p:nvSpPr>
-          <p:cNvPr id="27" name="Rounded Rectangle 26"/>
+          <p:cNvPr id="30" name="Rounded Rectangle 29"/>
           <p:cNvSpPr/>
           <p:nvPr/>
         </p:nvSpPr>
         <p:spPr>
           <a:xfrm>
-            <a:off x="7178040" y="4846320"/>
+            <a:off x="7178040" y="4754880"/>
             <a:ext cx="2103120" cy="1051560"/>
           </a:xfrm>
           <a:prstGeom prst="roundRect">
@@ -18443,7 +18951,7 @@
       </p:sp>
       <p:sp>
         <p:nvSpPr>
-          <p:cNvPr id="28" name="TextBox 27"/>
+          <p:cNvPr id="31" name="TextBox 30"/>
           <p:cNvSpPr txBox="1"/>
           <p:nvPr/>
         </p:nvSpPr>
@@ -18480,7 +18988,7 @@
       </p:sp>
       <p:sp>
         <p:nvSpPr>
-          <p:cNvPr id="29" name="TextBox 28"/>
+          <p:cNvPr id="32" name="TextBox 31"/>
           <p:cNvSpPr txBox="1"/>
           <p:nvPr/>
         </p:nvSpPr>
@@ -18517,13 +19025,13 @@
       </p:sp>
       <p:sp>
         <p:nvSpPr>
-          <p:cNvPr id="30" name="Rounded Rectangle 29"/>
+          <p:cNvPr id="33" name="Rounded Rectangle 32"/>
           <p:cNvSpPr/>
           <p:nvPr/>
         </p:nvSpPr>
         <p:spPr>
           <a:xfrm>
-            <a:off x="9372600" y="4846320"/>
+            <a:off x="9372600" y="4754880"/>
             <a:ext cx="2103120" cy="1051560"/>
           </a:xfrm>
           <a:prstGeom prst="roundRect">
@@ -18563,7 +19071,7 @@
       </p:sp>
       <p:sp>
         <p:nvSpPr>
-          <p:cNvPr id="31" name="TextBox 30"/>
+          <p:cNvPr id="34" name="TextBox 33"/>
           <p:cNvSpPr txBox="1"/>
           <p:nvPr/>
         </p:nvSpPr>
@@ -18600,7 +19108,7 @@
       </p:sp>
       <p:sp>
         <p:nvSpPr>
-          <p:cNvPr id="32" name="TextBox 31"/>
+          <p:cNvPr id="35" name="TextBox 34"/>
           <p:cNvSpPr txBox="1"/>
           <p:nvPr/>
         </p:nvSpPr>
@@ -18637,7 +19145,7 @@
       </p:sp>
       <p:sp>
         <p:nvSpPr>
-          <p:cNvPr id="33" name="Rectangle 32"/>
+          <p:cNvPr id="36" name="Rectangle 35"/>
           <p:cNvSpPr/>
           <p:nvPr/>
         </p:nvSpPr>
@@ -18681,7 +19189,7 @@
       </p:sp>
       <p:sp>
         <p:nvSpPr>
-          <p:cNvPr id="34" name="TextBox 33"/>
+          <p:cNvPr id="37" name="TextBox 36"/>
           <p:cNvSpPr txBox="1"/>
           <p:nvPr/>
         </p:nvSpPr>
@@ -18718,7 +19226,7 @@
       </p:sp>
       <p:sp>
         <p:nvSpPr>
-          <p:cNvPr id="35" name="TextBox 34"/>
+          <p:cNvPr id="38" name="TextBox 37"/>
           <p:cNvSpPr txBox="1"/>
           <p:nvPr/>
         </p:nvSpPr>
@@ -19010,8 +19518,8 @@
         </p:nvSpPr>
         <p:spPr>
           <a:xfrm>
-            <a:off x="548640" y="2011680"/>
-            <a:ext cx="10972800" cy="1051560"/>
+            <a:off x="548640" y="1965960"/>
+            <a:ext cx="10972800" cy="1417320"/>
           </a:xfrm>
           <a:prstGeom prst="roundRect">
             <a:avLst>
@@ -19056,31 +19564,31 @@
         </p:nvSpPr>
         <p:spPr>
           <a:xfrm>
-            <a:off x="868680" y="2148840"/>
-            <a:ext cx="10332720" cy="320040"/>
-          </a:xfrm>
-          <a:prstGeom prst="rect">
-            <a:avLst/>
-          </a:prstGeom>
-          <a:noFill/>
-        </p:spPr>
-        <p:txBody>
-          <a:bodyPr wrap="square" anchor="t">
-            <a:spAutoFit/>
-          </a:bodyPr>
-          <a:lstStyle/>
-          <a:p>
-            <a:pPr algn="l"/>
-            <a:r>
-              <a:rPr sz="1800" b="1">
+            <a:off x="868680" y="2057400"/>
+            <a:ext cx="2893161" cy="960120"/>
+          </a:xfrm>
+          <a:prstGeom prst="rect">
+            <a:avLst/>
+          </a:prstGeom>
+          <a:noFill/>
+        </p:spPr>
+        <p:txBody>
+          <a:bodyPr wrap="none" anchor="ctr">
+            <a:spAutoFit/>
+          </a:bodyPr>
+          <a:lstStyle/>
+          <a:p>
+            <a:pPr algn="r"/>
+            <a:r>
+              <a:rPr sz="2000" b="1">
                 <a:solidFill>
                   <a:srgbClr val="5234B7"/>
                 </a:solidFill>
-                <a:latin typeface="DIN Next LT W23"/>
-                <a:ea typeface="DIN Next LT W23"/>
-                <a:cs typeface="DIN Next LT W23"/>
-              </a:rPr>
-              <a:t>z = (x − μ) / σ</a:t>
+                <a:latin typeface="Helvetica Neue"/>
+                <a:ea typeface="Helvetica Neue"/>
+                <a:cs typeface="Helvetica Neue"/>
+              </a:rPr>
+              <a:t>z =</a:t>
             </a:r>
           </a:p>
         </p:txBody>
@@ -19093,29 +19601,147 @@
         </p:nvSpPr>
         <p:spPr>
           <a:xfrm>
-            <a:off x="868680" y="2560320"/>
-            <a:ext cx="10332720" cy="274320"/>
-          </a:xfrm>
-          <a:prstGeom prst="rect">
-            <a:avLst/>
-          </a:prstGeom>
-          <a:noFill/>
-        </p:spPr>
-        <p:txBody>
-          <a:bodyPr wrap="square" anchor="t">
-            <a:spAutoFit/>
-          </a:bodyPr>
-          <a:lstStyle/>
-          <a:p>
-            <a:pPr algn="l"/>
-            <a:r>
-              <a:rPr sz="1300" b="0">
+            <a:off x="3968496" y="2057400"/>
+            <a:ext cx="7026249" cy="364845"/>
+          </a:xfrm>
+          <a:prstGeom prst="rect">
+            <a:avLst/>
+          </a:prstGeom>
+          <a:noFill/>
+        </p:spPr>
+        <p:txBody>
+          <a:bodyPr wrap="none" anchor="b">
+            <a:spAutoFit/>
+          </a:bodyPr>
+          <a:lstStyle/>
+          <a:p>
+            <a:pPr algn="ctr"/>
+            <a:r>
+              <a:rPr sz="2000" b="1">
+                <a:solidFill>
+                  <a:srgbClr val="5234B7"/>
+                </a:solidFill>
+                <a:latin typeface="Helvetica Neue"/>
+                <a:ea typeface="Helvetica Neue"/>
+                <a:cs typeface="Helvetica Neue"/>
+              </a:rPr>
+              <a:t>x − μ</a:t>
+            </a:r>
+          </a:p>
+        </p:txBody>
+      </p:sp>
+      <p:sp>
+        <p:nvSpPr>
+          <p:cNvPr id="11" name="Rectangle 10"/>
+          <p:cNvSpPr/>
+          <p:nvPr/>
+        </p:nvSpPr>
+        <p:spPr>
+          <a:xfrm>
+            <a:off x="4319808" y="2462570"/>
+            <a:ext cx="6323624" cy="18288"/>
+          </a:xfrm>
+          <a:prstGeom prst="rect">
+            <a:avLst/>
+          </a:prstGeom>
+          <a:solidFill>
+            <a:srgbClr val="5234B7"/>
+          </a:solidFill>
+          <a:ln>
+            <a:noFill/>
+          </a:ln>
+          <a:effectLst/>
+        </p:spPr>
+        <p:style>
+          <a:lnRef idx="1">
+            <a:schemeClr val="accent1"/>
+          </a:lnRef>
+          <a:fillRef idx="3">
+            <a:schemeClr val="accent1"/>
+          </a:fillRef>
+          <a:effectRef idx="2">
+            <a:schemeClr val="accent1"/>
+          </a:effectRef>
+          <a:fontRef idx="minor">
+            <a:schemeClr val="lt1"/>
+          </a:fontRef>
+        </p:style>
+        <p:txBody>
+          <a:bodyPr rtlCol="0" anchor="ctr"/>
+          <a:lstStyle/>
+          <a:p>
+            <a:pPr algn="ctr"/>
+          </a:p>
+        </p:txBody>
+      </p:sp>
+      <p:sp>
+        <p:nvSpPr>
+          <p:cNvPr id="12" name="TextBox 11"/>
+          <p:cNvSpPr txBox="1"/>
+          <p:nvPr/>
+        </p:nvSpPr>
+        <p:spPr>
+          <a:xfrm>
+            <a:off x="3968496" y="2537460"/>
+            <a:ext cx="7026249" cy="364845"/>
+          </a:xfrm>
+          <a:prstGeom prst="rect">
+            <a:avLst/>
+          </a:prstGeom>
+          <a:noFill/>
+        </p:spPr>
+        <p:txBody>
+          <a:bodyPr wrap="none" anchor="t">
+            <a:spAutoFit/>
+          </a:bodyPr>
+          <a:lstStyle/>
+          <a:p>
+            <a:pPr algn="ctr"/>
+            <a:r>
+              <a:rPr sz="2000" b="1">
+                <a:solidFill>
+                  <a:srgbClr val="5234B7"/>
+                </a:solidFill>
+                <a:latin typeface="Helvetica Neue"/>
+                <a:ea typeface="Helvetica Neue"/>
+                <a:cs typeface="Helvetica Neue"/>
+              </a:rPr>
+              <a:t>σ</a:t>
+            </a:r>
+          </a:p>
+        </p:txBody>
+      </p:sp>
+      <p:sp>
+        <p:nvSpPr>
+          <p:cNvPr id="13" name="TextBox 12"/>
+          <p:cNvSpPr txBox="1"/>
+          <p:nvPr/>
+        </p:nvSpPr>
+        <p:spPr>
+          <a:xfrm>
+            <a:off x="868680" y="3017520"/>
+            <a:ext cx="10332720" cy="256032"/>
+          </a:xfrm>
+          <a:prstGeom prst="rect">
+            <a:avLst/>
+          </a:prstGeom>
+          <a:noFill/>
+        </p:spPr>
+        <p:txBody>
+          <a:bodyPr wrap="square" anchor="t">
+            <a:spAutoFit/>
+          </a:bodyPr>
+          <a:lstStyle/>
+          <a:p>
+            <a:pPr algn="l"/>
+            <a:r>
+              <a:rPr sz="1200" b="0">
                 <a:solidFill>
                   <a:srgbClr val="5A5470"/>
                 </a:solidFill>
-                <a:latin typeface="DIN Next LT W23"/>
-                <a:ea typeface="DIN Next LT W23"/>
-                <a:cs typeface="DIN Next LT W23"/>
+                <a:latin typeface="Helvetica Neue"/>
+                <a:ea typeface="Helvetica Neue"/>
+                <a:cs typeface="Helvetica Neue"/>
               </a:rPr>
               <a:t>Mean: μ = 60 · Standard deviation: σ = 28.28</a:t>
             </a:r>
@@ -19124,15 +19750,15 @@
       </p:sp>
       <p:graphicFrame>
         <p:nvGraphicFramePr>
-          <p:cNvPr id="11" name="Table 10"/>
+          <p:cNvPr id="14" name="Table 13"/>
           <p:cNvGraphicFramePr>
             <a:graphicFrameLocks noGrp="1"/>
           </p:cNvGraphicFramePr>
           <p:nvPr/>
         </p:nvGraphicFramePr>
         <p:xfrm>
-          <a:off x="548640" y="3246120"/>
-          <a:ext cx="10972800" cy="2240280"/>
+          <a:off x="548640" y="3566160"/>
+          <a:ext cx="10972800" cy="2011680"/>
         </p:xfrm>
         <a:graphic>
           <a:graphicData uri="http://schemas.openxmlformats.org/drawingml/2006/table">
@@ -19144,7 +19770,7 @@
                 <a:gridCol w="5486400"/>
                 <a:gridCol w="5486400"/>
               </a:tblGrid>
-              <a:tr h="373380">
+              <a:tr h="335280">
                 <a:tc>
                   <a:txBody>
                     <a:bodyPr/>
@@ -19192,7 +19818,7 @@
                   </a:tcPr>
                 </a:tc>
               </a:tr>
-              <a:tr h="373380">
+              <a:tr h="335280">
                 <a:tc>
                   <a:txBody>
                     <a:bodyPr/>
@@ -19240,7 +19866,7 @@
                   </a:tcPr>
                 </a:tc>
               </a:tr>
-              <a:tr h="373380">
+              <a:tr h="335280">
                 <a:tc>
                   <a:txBody>
                     <a:bodyPr/>
@@ -19288,7 +19914,7 @@
                   </a:tcPr>
                 </a:tc>
               </a:tr>
-              <a:tr h="373380">
+              <a:tr h="335280">
                 <a:tc>
                   <a:txBody>
                     <a:bodyPr/>
@@ -19336,7 +19962,7 @@
                   </a:tcPr>
                 </a:tc>
               </a:tr>
-              <a:tr h="373380">
+              <a:tr h="335280">
                 <a:tc>
                   <a:txBody>
                     <a:bodyPr/>
@@ -19384,7 +20010,7 @@
                   </a:tcPr>
                 </a:tc>
               </a:tr>
-              <a:tr h="373380">
+              <a:tr h="335280">
                 <a:tc>
                   <a:txBody>
                     <a:bodyPr/>
@@ -19438,7 +20064,7 @@
       </p:graphicFrame>
       <p:sp>
         <p:nvSpPr>
-          <p:cNvPr id="12" name="TextBox 11"/>
+          <p:cNvPr id="15" name="TextBox 14"/>
           <p:cNvSpPr txBox="1"/>
           <p:nvPr/>
         </p:nvSpPr>
@@ -19475,7 +20101,7 @@
       </p:sp>
       <p:sp>
         <p:nvSpPr>
-          <p:cNvPr id="13" name="Rectangle 12"/>
+          <p:cNvPr id="16" name="Rectangle 15"/>
           <p:cNvSpPr/>
           <p:nvPr/>
         </p:nvSpPr>
@@ -19519,7 +20145,7 @@
       </p:sp>
       <p:sp>
         <p:nvSpPr>
-          <p:cNvPr id="14" name="TextBox 13"/>
+          <p:cNvPr id="17" name="TextBox 16"/>
           <p:cNvSpPr txBox="1"/>
           <p:nvPr/>
         </p:nvSpPr>
@@ -19556,7 +20182,7 @@
       </p:sp>
       <p:sp>
         <p:nvSpPr>
-          <p:cNvPr id="15" name="TextBox 14"/>
+          <p:cNvPr id="18" name="TextBox 17"/>
           <p:cNvSpPr txBox="1"/>
           <p:nvPr/>
         </p:nvSpPr>
@@ -43674,52 +44300,51 @@
         </p:nvSpPr>
         <p:spPr>
           <a:xfrm>
-            <a:off x="868680" y="2377440"/>
-            <a:ext cx="10332720" cy="457200"/>
-          </a:xfrm>
-          <a:prstGeom prst="rect">
-            <a:avLst/>
-          </a:prstGeom>
-          <a:noFill/>
-        </p:spPr>
-        <p:txBody>
-          <a:bodyPr wrap="square" anchor="t">
-            <a:spAutoFit/>
-          </a:bodyPr>
-          <a:lstStyle/>
-          <a:p>
-            <a:pPr algn="l"/>
-            <a:r>
-              <a:rPr sz="2200" b="1">
+            <a:off x="868680" y="2331720"/>
+            <a:ext cx="10332720" cy="640080"/>
+          </a:xfrm>
+          <a:prstGeom prst="rect">
+            <a:avLst/>
+          </a:prstGeom>
+          <a:noFill/>
+        </p:spPr>
+        <p:txBody>
+          <a:bodyPr wrap="square" anchor="t">
+            <a:spAutoFit/>
+          </a:bodyPr>
+          <a:lstStyle/>
+          <a:p>
+            <a:pPr algn="ctr"/>
+            <a:r>
+              <a:rPr sz="2600" b="1">
                 <a:solidFill>
                   <a:srgbClr val="5234B7"/>
                 </a:solidFill>
-                <a:latin typeface="DIN Next LT W23"/>
-                <a:ea typeface="DIN Next LT W23"/>
-                <a:cs typeface="DIN Next LT W23"/>
+                <a:latin typeface="Helvetica Neue"/>
+                <a:ea typeface="Helvetica Neue"/>
+                <a:cs typeface="Helvetica Neue"/>
               </a:rPr>
               <a:t>Study Hours</a:t>
             </a:r>
             <a:r>
-              <a:rPr sz="1600" b="1">
+              <a:rPr sz="2200" b="1" baseline="-25000">
                 <a:solidFill>
                   <a:srgbClr val="5234B7"/>
                 </a:solidFill>
-                <a:latin typeface="DIN Next LT W23"/>
-                <a:ea typeface="DIN Next LT W23"/>
-                <a:cs typeface="DIN Next LT W23"/>
-                <a:baseline val="-25000"/>
+                <a:latin typeface="Helvetica Neue"/>
+                <a:ea typeface="Helvetica Neue"/>
+                <a:cs typeface="Helvetica Neue"/>
               </a:rPr>
               <a:t>C</a:t>
             </a:r>
             <a:r>
-              <a:rPr sz="2200" b="1">
+              <a:rPr sz="2600" b="1">
                 <a:solidFill>
                   <a:srgbClr val="5234B7"/>
                 </a:solidFill>
-                <a:latin typeface="DIN Next LT W23"/>
-                <a:ea typeface="DIN Next LT W23"/>
-                <a:cs typeface="DIN Next LT W23"/>
+                <a:latin typeface="Helvetica Neue"/>
+                <a:ea typeface="Helvetica Neue"/>
+                <a:cs typeface="Helvetica Neue"/>
               </a:rPr>
               <a:t> = (8 + 7) / 2 = 7.5</a:t>
             </a:r>
@@ -45152,52 +45777,51 @@
         </p:nvSpPr>
         <p:spPr>
           <a:xfrm>
-            <a:off x="868680" y="2377440"/>
-            <a:ext cx="10332720" cy="457200"/>
-          </a:xfrm>
-          <a:prstGeom prst="rect">
-            <a:avLst/>
-          </a:prstGeom>
-          <a:noFill/>
-        </p:spPr>
-        <p:txBody>
-          <a:bodyPr wrap="square" anchor="t">
-            <a:spAutoFit/>
-          </a:bodyPr>
-          <a:lstStyle/>
-          <a:p>
-            <a:pPr algn="l"/>
-            <a:r>
-              <a:rPr sz="2200" b="1">
+            <a:off x="868680" y="2331720"/>
+            <a:ext cx="10332720" cy="640080"/>
+          </a:xfrm>
+          <a:prstGeom prst="rect">
+            <a:avLst/>
+          </a:prstGeom>
+          <a:noFill/>
+        </p:spPr>
+        <p:txBody>
+          <a:bodyPr wrap="square" anchor="t">
+            <a:spAutoFit/>
+          </a:bodyPr>
+          <a:lstStyle/>
+          <a:p>
+            <a:pPr algn="ctr"/>
+            <a:r>
+              <a:rPr sz="2600" b="1">
                 <a:solidFill>
                   <a:srgbClr val="5234B7"/>
                 </a:solidFill>
-                <a:latin typeface="DIN Next LT W23"/>
-                <a:ea typeface="DIN Next LT W23"/>
-                <a:cs typeface="DIN Next LT W23"/>
+                <a:latin typeface="Helvetica Neue"/>
+                <a:ea typeface="Helvetica Neue"/>
+                <a:cs typeface="Helvetica Neue"/>
               </a:rPr>
               <a:t>Study Hours</a:t>
             </a:r>
             <a:r>
-              <a:rPr sz="1600" b="1">
+              <a:rPr sz="2200" b="1" baseline="-25000">
                 <a:solidFill>
                   <a:srgbClr val="5234B7"/>
                 </a:solidFill>
-                <a:latin typeface="DIN Next LT W23"/>
-                <a:ea typeface="DIN Next LT W23"/>
-                <a:cs typeface="DIN Next LT W23"/>
-                <a:baseline val="-25000"/>
+                <a:latin typeface="Helvetica Neue"/>
+                <a:ea typeface="Helvetica Neue"/>
+                <a:cs typeface="Helvetica Neue"/>
               </a:rPr>
               <a:t>C</a:t>
             </a:r>
             <a:r>
-              <a:rPr sz="2200" b="1">
+              <a:rPr sz="2600" b="1">
                 <a:solidFill>
                   <a:srgbClr val="5234B7"/>
                 </a:solidFill>
-                <a:latin typeface="DIN Next LT W23"/>
-                <a:ea typeface="DIN Next LT W23"/>
-                <a:cs typeface="DIN Next LT W23"/>
+                <a:latin typeface="Helvetica Neue"/>
+                <a:ea typeface="Helvetica Neue"/>
+                <a:cs typeface="Helvetica Neue"/>
               </a:rPr>
               <a:t> ≈ 7.6</a:t>
             </a:r>

</xml_diff>

<commit_message>
feat: enhance diagram handling in PowerPoint generation script by updating add_diagram function for better aspect ratio management and adjusting diagram placements for improved visual clarity
</commit_message>
<xml_diff>
--- a/web-presentation/pdf-exports/Week1-Session1-Foundations.pptx
+++ b/web-presentation/pdf-exports/Week1-Session1-Foundations.pptx
@@ -3765,8 +3765,8 @@
         </p:blipFill>
         <p:spPr>
           <a:xfrm>
-            <a:off x="548640" y="2331720"/>
-            <a:ext cx="10972800" cy="3552529"/>
+            <a:off x="2928272" y="2331720"/>
+            <a:ext cx="6213534" cy="2011680"/>
           </a:xfrm>
           <a:prstGeom prst="rect">
             <a:avLst/>
@@ -5456,8 +5456,8 @@
         </p:blipFill>
         <p:spPr>
           <a:xfrm>
-            <a:off x="548640" y="2971800"/>
-            <a:ext cx="10972800" cy="3969973"/>
+            <a:off x="2244008" y="2926080"/>
+            <a:ext cx="7582063" cy="2743200"/>
           </a:xfrm>
           <a:prstGeom prst="rect">
             <a:avLst/>
@@ -5472,7 +5472,7 @@
         </p:nvSpPr>
         <p:spPr>
           <a:xfrm>
-            <a:off x="548640" y="5806440"/>
+            <a:off x="548640" y="5852160"/>
             <a:ext cx="10972800" cy="274320"/>
           </a:xfrm>
           <a:prstGeom prst="rect">
@@ -5884,8 +5884,8 @@
         </p:blipFill>
         <p:spPr>
           <a:xfrm>
-            <a:off x="548640" y="2011680"/>
-            <a:ext cx="10972800" cy="3969973"/>
+            <a:off x="2244008" y="2011680"/>
+            <a:ext cx="7582063" cy="2743200"/>
           </a:xfrm>
           <a:prstGeom prst="rect">
             <a:avLst/>
@@ -5900,7 +5900,7 @@
         </p:nvSpPr>
         <p:spPr>
           <a:xfrm>
-            <a:off x="548640" y="4709160"/>
+            <a:off x="548640" y="4937760"/>
             <a:ext cx="320040" cy="365760"/>
           </a:xfrm>
           <a:prstGeom prst="rect">
@@ -5937,7 +5937,7 @@
         </p:nvSpPr>
         <p:spPr>
           <a:xfrm>
-            <a:off x="914400" y="4709160"/>
+            <a:off x="914400" y="4937760"/>
             <a:ext cx="10241280" cy="411480"/>
           </a:xfrm>
           <a:prstGeom prst="rect">
@@ -5974,7 +5974,7 @@
         </p:nvSpPr>
         <p:spPr>
           <a:xfrm>
-            <a:off x="548640" y="5330952"/>
+            <a:off x="548640" y="5559552"/>
             <a:ext cx="320040" cy="365760"/>
           </a:xfrm>
           <a:prstGeom prst="rect">
@@ -6011,7 +6011,7 @@
         </p:nvSpPr>
         <p:spPr>
           <a:xfrm>
-            <a:off x="914400" y="5330952"/>
+            <a:off x="914400" y="5559552"/>
             <a:ext cx="10241280" cy="411480"/>
           </a:xfrm>
           <a:prstGeom prst="rect">
@@ -6048,7 +6048,7 @@
         </p:nvSpPr>
         <p:spPr>
           <a:xfrm>
-            <a:off x="548640" y="5952744"/>
+            <a:off x="548640" y="6181344"/>
             <a:ext cx="320040" cy="365760"/>
           </a:xfrm>
           <a:prstGeom prst="rect">
@@ -6085,7 +6085,7 @@
         </p:nvSpPr>
         <p:spPr>
           <a:xfrm>
-            <a:off x="914400" y="5952744"/>
+            <a:off x="914400" y="6181344"/>
             <a:ext cx="10241280" cy="411480"/>
           </a:xfrm>
           <a:prstGeom prst="rect">
@@ -6580,8 +6580,8 @@
         </p:blipFill>
         <p:spPr>
           <a:xfrm>
-            <a:off x="548640" y="2971800"/>
-            <a:ext cx="10972800" cy="5209309"/>
+            <a:off x="3145925" y="2926080"/>
+            <a:ext cx="5778229" cy="2743200"/>
           </a:xfrm>
           <a:prstGeom prst="rect">
             <a:avLst/>
@@ -6971,8 +6971,8 @@
         </p:blipFill>
         <p:spPr>
           <a:xfrm>
-            <a:off x="548640" y="2011680"/>
-            <a:ext cx="10972800" cy="5209309"/>
+            <a:off x="3145925" y="2011680"/>
+            <a:ext cx="5778229" cy="2743200"/>
           </a:xfrm>
           <a:prstGeom prst="rect">
             <a:avLst/>
@@ -6987,7 +6987,7 @@
         </p:nvSpPr>
         <p:spPr>
           <a:xfrm>
-            <a:off x="548640" y="4709160"/>
+            <a:off x="548640" y="4937760"/>
             <a:ext cx="320040" cy="365760"/>
           </a:xfrm>
           <a:prstGeom prst="rect">
@@ -7024,7 +7024,7 @@
         </p:nvSpPr>
         <p:spPr>
           <a:xfrm>
-            <a:off x="914400" y="4709160"/>
+            <a:off x="914400" y="4937760"/>
             <a:ext cx="10241280" cy="411480"/>
           </a:xfrm>
           <a:prstGeom prst="rect">
@@ -7061,7 +7061,7 @@
         </p:nvSpPr>
         <p:spPr>
           <a:xfrm>
-            <a:off x="548640" y="5330952"/>
+            <a:off x="548640" y="5559552"/>
             <a:ext cx="320040" cy="365760"/>
           </a:xfrm>
           <a:prstGeom prst="rect">
@@ -7098,7 +7098,7 @@
         </p:nvSpPr>
         <p:spPr>
           <a:xfrm>
-            <a:off x="914400" y="5330952"/>
+            <a:off x="914400" y="5559552"/>
             <a:ext cx="10241280" cy="411480"/>
           </a:xfrm>
           <a:prstGeom prst="rect">
@@ -7135,7 +7135,7 @@
         </p:nvSpPr>
         <p:spPr>
           <a:xfrm>
-            <a:off x="548640" y="5952744"/>
+            <a:off x="548640" y="6181344"/>
             <a:ext cx="320040" cy="365760"/>
           </a:xfrm>
           <a:prstGeom prst="rect">
@@ -7172,7 +7172,7 @@
         </p:nvSpPr>
         <p:spPr>
           <a:xfrm>
-            <a:off x="914400" y="5952744"/>
+            <a:off x="914400" y="6181344"/>
             <a:ext cx="10241280" cy="411480"/>
           </a:xfrm>
           <a:prstGeom prst="rect">
@@ -9840,7 +9840,7 @@
         <p:spPr>
           <a:xfrm>
             <a:off x="5852160" y="2423160"/>
-            <a:ext cx="5669280" cy="1904842"/>
+            <a:ext cx="5669280" cy="1904841"/>
           </a:xfrm>
           <a:prstGeom prst="rect">
             <a:avLst/>
@@ -10653,8 +10653,8 @@
         </p:blipFill>
         <p:spPr>
           <a:xfrm>
-            <a:off x="5852160" y="2423160"/>
-            <a:ext cx="5669280" cy="2543315"/>
+            <a:off x="6444691" y="2423160"/>
+            <a:ext cx="4484217" cy="2011680"/>
           </a:xfrm>
           <a:prstGeom prst="rect">
             <a:avLst/>
@@ -23564,8 +23564,8 @@
         </p:blipFill>
         <p:spPr>
           <a:xfrm>
-            <a:off x="548640" y="2286000"/>
-            <a:ext cx="10972800" cy="4876800"/>
+            <a:off x="2948940" y="2286000"/>
+            <a:ext cx="6172200" cy="2743200"/>
           </a:xfrm>
           <a:prstGeom prst="rect">
             <a:avLst/>
@@ -23580,7 +23580,7 @@
         </p:nvSpPr>
         <p:spPr>
           <a:xfrm>
-            <a:off x="548640" y="5669280"/>
+            <a:off x="548640" y="5257800"/>
             <a:ext cx="10972800" cy="320040"/>
           </a:xfrm>
           <a:prstGeom prst="rect">
@@ -34900,8 +34900,8 @@
         </p:blipFill>
         <p:spPr>
           <a:xfrm>
-            <a:off x="548640" y="2011680"/>
-            <a:ext cx="10972800" cy="4673600"/>
+            <a:off x="2814761" y="2011680"/>
+            <a:ext cx="6440556" cy="2743200"/>
           </a:xfrm>
           <a:prstGeom prst="rect">
             <a:avLst/>
@@ -34916,7 +34916,7 @@
         </p:nvSpPr>
         <p:spPr>
           <a:xfrm>
-            <a:off x="548640" y="5074920"/>
+            <a:off x="548640" y="4983480"/>
             <a:ext cx="10972800" cy="868680"/>
           </a:xfrm>
           <a:prstGeom prst="roundRect">
@@ -34962,7 +34962,7 @@
         </p:nvSpPr>
         <p:spPr>
           <a:xfrm>
-            <a:off x="868680" y="5257800"/>
+            <a:off x="868680" y="5166360"/>
             <a:ext cx="10332720" cy="502920"/>
           </a:xfrm>
           <a:prstGeom prst="rect">
@@ -36798,8 +36798,8 @@
         </p:blipFill>
         <p:spPr>
           <a:xfrm>
-            <a:off x="548640" y="2011680"/>
-            <a:ext cx="10972800" cy="3765511"/>
+            <a:off x="3103994" y="2011680"/>
+            <a:ext cx="5862090" cy="2011680"/>
           </a:xfrm>
           <a:prstGeom prst="rect">
             <a:avLst/>
@@ -36814,7 +36814,7 @@
         </p:nvSpPr>
         <p:spPr>
           <a:xfrm>
-            <a:off x="548640" y="4160520"/>
+            <a:off x="548640" y="4206240"/>
             <a:ext cx="3429000" cy="1691640"/>
           </a:xfrm>
           <a:prstGeom prst="roundRect">
@@ -36860,7 +36860,7 @@
         </p:nvSpPr>
         <p:spPr>
           <a:xfrm>
-            <a:off x="777240" y="4389120"/>
+            <a:off x="777240" y="4434840"/>
             <a:ext cx="2926080" cy="320040"/>
           </a:xfrm>
           <a:prstGeom prst="rect">
@@ -36897,7 +36897,7 @@
         </p:nvSpPr>
         <p:spPr>
           <a:xfrm>
-            <a:off x="777240" y="4846320"/>
+            <a:off x="777240" y="4892040"/>
             <a:ext cx="2926080" cy="822960"/>
           </a:xfrm>
           <a:prstGeom prst="rect">
@@ -36934,7 +36934,7 @@
         </p:nvSpPr>
         <p:spPr>
           <a:xfrm>
-            <a:off x="4178808" y="4160520"/>
+            <a:off x="4178808" y="4206240"/>
             <a:ext cx="3429000" cy="1691640"/>
           </a:xfrm>
           <a:prstGeom prst="roundRect">
@@ -36980,7 +36980,7 @@
         </p:nvSpPr>
         <p:spPr>
           <a:xfrm>
-            <a:off x="4407408" y="4389120"/>
+            <a:off x="4407408" y="4434840"/>
             <a:ext cx="2926080" cy="320040"/>
           </a:xfrm>
           <a:prstGeom prst="rect">
@@ -37017,7 +37017,7 @@
         </p:nvSpPr>
         <p:spPr>
           <a:xfrm>
-            <a:off x="4407408" y="4846320"/>
+            <a:off x="4407408" y="4892040"/>
             <a:ext cx="2926080" cy="822960"/>
           </a:xfrm>
           <a:prstGeom prst="rect">
@@ -37054,7 +37054,7 @@
         </p:nvSpPr>
         <p:spPr>
           <a:xfrm>
-            <a:off x="7808976" y="4160520"/>
+            <a:off x="7808976" y="4206240"/>
             <a:ext cx="3429000" cy="1691640"/>
           </a:xfrm>
           <a:prstGeom prst="roundRect">
@@ -37100,7 +37100,7 @@
         </p:nvSpPr>
         <p:spPr>
           <a:xfrm>
-            <a:off x="8037576" y="4389120"/>
+            <a:off x="8037576" y="4434840"/>
             <a:ext cx="2926080" cy="320040"/>
           </a:xfrm>
           <a:prstGeom prst="rect">
@@ -37137,7 +37137,7 @@
         </p:nvSpPr>
         <p:spPr>
           <a:xfrm>
-            <a:off x="8037576" y="4846320"/>
+            <a:off x="8037576" y="4892040"/>
             <a:ext cx="2926080" cy="822960"/>
           </a:xfrm>
           <a:prstGeom prst="rect">
@@ -40788,8 +40788,8 @@
         </p:blipFill>
         <p:spPr>
           <a:xfrm>
-            <a:off x="548640" y="2788920"/>
-            <a:ext cx="10972800" cy="5059953"/>
+            <a:off x="3457232" y="2788920"/>
+            <a:ext cx="5155615" cy="2377440"/>
           </a:xfrm>
           <a:prstGeom prst="rect">
             <a:avLst/>
@@ -40804,7 +40804,7 @@
         </p:nvSpPr>
         <p:spPr>
           <a:xfrm>
-            <a:off x="548640" y="5349240"/>
+            <a:off x="548640" y="5394960"/>
             <a:ext cx="320040" cy="365760"/>
           </a:xfrm>
           <a:prstGeom prst="rect">
@@ -40841,7 +40841,7 @@
         </p:nvSpPr>
         <p:spPr>
           <a:xfrm>
-            <a:off x="914400" y="5349240"/>
+            <a:off x="914400" y="5394960"/>
             <a:ext cx="10241280" cy="411480"/>
           </a:xfrm>
           <a:prstGeom prst="rect">
@@ -40878,7 +40878,7 @@
         </p:nvSpPr>
         <p:spPr>
           <a:xfrm>
-            <a:off x="548640" y="5971032"/>
+            <a:off x="548640" y="6016752"/>
             <a:ext cx="320040" cy="365760"/>
           </a:xfrm>
           <a:prstGeom prst="rect">
@@ -40915,7 +40915,7 @@
         </p:nvSpPr>
         <p:spPr>
           <a:xfrm>
-            <a:off x="914400" y="5971032"/>
+            <a:off x="914400" y="6016752"/>
             <a:ext cx="10241280" cy="411480"/>
           </a:xfrm>
           <a:prstGeom prst="rect">
@@ -45608,8 +45608,8 @@
         </p:blipFill>
         <p:spPr>
           <a:xfrm>
-            <a:off x="548640" y="4297680"/>
-            <a:ext cx="10972800" cy="3552529"/>
+            <a:off x="3493139" y="4572000"/>
+            <a:ext cx="5083800" cy="1645920"/>
           </a:xfrm>
           <a:prstGeom prst="rect">
             <a:avLst/>
@@ -47509,8 +47509,8 @@
         </p:blipFill>
         <p:spPr>
           <a:xfrm>
-            <a:off x="548640" y="2011680"/>
-            <a:ext cx="10972800" cy="3964886"/>
+            <a:off x="2239144" y="2011680"/>
+            <a:ext cx="7591790" cy="2743200"/>
           </a:xfrm>
           <a:prstGeom prst="rect">
             <a:avLst/>
@@ -47525,7 +47525,7 @@
         </p:nvSpPr>
         <p:spPr>
           <a:xfrm>
-            <a:off x="548640" y="5074920"/>
+            <a:off x="548640" y="4983480"/>
             <a:ext cx="10972800" cy="868680"/>
           </a:xfrm>
           <a:prstGeom prst="roundRect">
@@ -47571,7 +47571,7 @@
         </p:nvSpPr>
         <p:spPr>
           <a:xfrm>
-            <a:off x="868680" y="5257800"/>
+            <a:off x="868680" y="5166360"/>
             <a:ext cx="10332720" cy="502920"/>
           </a:xfrm>
           <a:prstGeom prst="rect">
@@ -47983,8 +47983,8 @@
         </p:blipFill>
         <p:spPr>
           <a:xfrm>
-            <a:off x="548640" y="2103120"/>
-            <a:ext cx="10972800" cy="3969973"/>
+            <a:off x="2244008" y="2103120"/>
+            <a:ext cx="7582063" cy="2743200"/>
           </a:xfrm>
           <a:prstGeom prst="rect">
             <a:avLst/>
@@ -47999,8 +47999,8 @@
         </p:nvSpPr>
         <p:spPr>
           <a:xfrm>
-            <a:off x="548640" y="4892040"/>
-            <a:ext cx="10972800" cy="1051560"/>
+            <a:off x="548640" y="5029200"/>
+            <a:ext cx="10972800" cy="914400"/>
           </a:xfrm>
           <a:prstGeom prst="roundRect">
             <a:avLst>
@@ -48045,8 +48045,8 @@
         </p:nvSpPr>
         <p:spPr>
           <a:xfrm>
-            <a:off x="914400" y="5120640"/>
-            <a:ext cx="10241280" cy="640080"/>
+            <a:off x="914400" y="5212080"/>
+            <a:ext cx="10241280" cy="594360"/>
           </a:xfrm>
           <a:prstGeom prst="rect">
             <a:avLst/>

</xml_diff>